<commit_message>
fix: PPT完美居中 — 根因是pptxgenjs 16x9=10"非13.33", LX=(10-CW)/2=0.5"
</commit_message>
<xml_diff>
--- a/docs/AI-Native-训战营-介绍与日程.pptx
+++ b/docs/AI-Native-训战营-介绍与日程.pptx
@@ -1328,7 +1328,7 @@
         </p:nvSpPr>
         <p:spPr>
           <a:xfrm>
-            <a:off x="1260043" y="4892040"/>
+            <a:off x="457200" y="4892040"/>
             <a:ext cx="8229600" cy="27432"/>
           </a:xfrm>
           <a:prstGeom prst="rect">
@@ -1348,7 +1348,7 @@
         </p:nvSpPr>
         <p:spPr>
           <a:xfrm>
-            <a:off x="1260043" y="4983480"/>
+            <a:off x="457200" y="4983480"/>
             <a:ext cx="8229600" cy="182880"/>
           </a:xfrm>
           <a:prstGeom prst="rect">
@@ -1384,7 +1384,7 @@
         </p:nvSpPr>
         <p:spPr>
           <a:xfrm>
-            <a:off x="1260043" y="594360"/>
+            <a:off x="457200" y="594360"/>
             <a:ext cx="1389888" cy="182880"/>
           </a:xfrm>
           <a:prstGeom prst="roundRect">
@@ -1406,7 +1406,7 @@
         </p:nvSpPr>
         <p:spPr>
           <a:xfrm>
-            <a:off x="1260043" y="594360"/>
+            <a:off x="457200" y="594360"/>
             <a:ext cx="1389888" cy="182880"/>
           </a:xfrm>
           <a:prstGeom prst="rect">
@@ -1445,7 +1445,7 @@
         </p:nvSpPr>
         <p:spPr>
           <a:xfrm>
-            <a:off x="3271723" y="594360"/>
+            <a:off x="2468880" y="594360"/>
             <a:ext cx="1271016" cy="182880"/>
           </a:xfrm>
           <a:prstGeom prst="roundRect">
@@ -1467,7 +1467,7 @@
         </p:nvSpPr>
         <p:spPr>
           <a:xfrm>
-            <a:off x="3271723" y="594360"/>
+            <a:off x="2468880" y="594360"/>
             <a:ext cx="1271016" cy="182880"/>
           </a:xfrm>
           <a:prstGeom prst="rect">
@@ -1506,7 +1506,7 @@
         </p:nvSpPr>
         <p:spPr>
           <a:xfrm>
-            <a:off x="1260043" y="1005840"/>
+            <a:off x="457200" y="1005840"/>
             <a:ext cx="8229600" cy="548640"/>
           </a:xfrm>
           <a:prstGeom prst="rect">
@@ -1545,7 +1545,7 @@
         </p:nvSpPr>
         <p:spPr>
           <a:xfrm>
-            <a:off x="1260043" y="1508760"/>
+            <a:off x="457200" y="1508760"/>
             <a:ext cx="8229600" cy="548640"/>
           </a:xfrm>
           <a:prstGeom prst="rect">
@@ -1584,7 +1584,7 @@
         </p:nvSpPr>
         <p:spPr>
           <a:xfrm>
-            <a:off x="1260043" y="2057400"/>
+            <a:off x="457200" y="2057400"/>
             <a:ext cx="8229600" cy="228600"/>
           </a:xfrm>
           <a:prstGeom prst="rect">
@@ -1620,7 +1620,7 @@
         </p:nvSpPr>
         <p:spPr>
           <a:xfrm>
-            <a:off x="1260043" y="2423160"/>
+            <a:off x="457200" y="2423160"/>
             <a:ext cx="8229600" cy="457200"/>
           </a:xfrm>
           <a:prstGeom prst="roundRect">
@@ -1647,7 +1647,7 @@
         </p:nvSpPr>
         <p:spPr>
           <a:xfrm>
-            <a:off x="1488643" y="2450592"/>
+            <a:off x="685800" y="2450592"/>
             <a:ext cx="7772400" cy="402336"/>
           </a:xfrm>
           <a:prstGeom prst="rect">
@@ -1683,7 +1683,7 @@
         </p:nvSpPr>
         <p:spPr>
           <a:xfrm>
-            <a:off x="1260043" y="3063240"/>
+            <a:off x="457200" y="3063240"/>
             <a:ext cx="2651760" cy="914400"/>
           </a:xfrm>
           <a:prstGeom prst="roundRect">
@@ -1710,7 +1710,7 @@
         </p:nvSpPr>
         <p:spPr>
           <a:xfrm>
-            <a:off x="1333195" y="3090672"/>
+            <a:off x="530352" y="3090672"/>
             <a:ext cx="2505456" cy="182880"/>
           </a:xfrm>
           <a:prstGeom prst="rect">
@@ -1749,7 +1749,7 @@
         </p:nvSpPr>
         <p:spPr>
           <a:xfrm>
-            <a:off x="1333195" y="3273552"/>
+            <a:off x="530352" y="3273552"/>
             <a:ext cx="2505456" cy="676656"/>
           </a:xfrm>
           <a:prstGeom prst="rect">
@@ -1822,7 +1822,7 @@
         </p:nvSpPr>
         <p:spPr>
           <a:xfrm>
-            <a:off x="4048963" y="3063240"/>
+            <a:off x="3246120" y="3063240"/>
             <a:ext cx="2651760" cy="914400"/>
           </a:xfrm>
           <a:prstGeom prst="roundRect">
@@ -1849,7 +1849,7 @@
         </p:nvSpPr>
         <p:spPr>
           <a:xfrm>
-            <a:off x="4122115" y="3090672"/>
+            <a:off x="3319272" y="3090672"/>
             <a:ext cx="2505456" cy="182880"/>
           </a:xfrm>
           <a:prstGeom prst="rect">
@@ -1888,7 +1888,7 @@
         </p:nvSpPr>
         <p:spPr>
           <a:xfrm>
-            <a:off x="4122115" y="3273552"/>
+            <a:off x="3319272" y="3273552"/>
             <a:ext cx="2505456" cy="676656"/>
           </a:xfrm>
           <a:prstGeom prst="rect">
@@ -1961,7 +1961,7 @@
         </p:nvSpPr>
         <p:spPr>
           <a:xfrm>
-            <a:off x="6837883" y="3063240"/>
+            <a:off x="6035040" y="3063240"/>
             <a:ext cx="2651760" cy="914400"/>
           </a:xfrm>
           <a:prstGeom prst="roundRect">
@@ -1988,7 +1988,7 @@
         </p:nvSpPr>
         <p:spPr>
           <a:xfrm>
-            <a:off x="6911035" y="3090672"/>
+            <a:off x="6108192" y="3090672"/>
             <a:ext cx="2505456" cy="182880"/>
           </a:xfrm>
           <a:prstGeom prst="rect">
@@ -2027,7 +2027,7 @@
         </p:nvSpPr>
         <p:spPr>
           <a:xfrm>
-            <a:off x="6911035" y="3273552"/>
+            <a:off x="6108192" y="3273552"/>
             <a:ext cx="2505456" cy="676656"/>
           </a:xfrm>
           <a:prstGeom prst="rect">
@@ -2132,7 +2132,7 @@
         </p:nvSpPr>
         <p:spPr>
           <a:xfrm>
-            <a:off x="1260043" y="4892040"/>
+            <a:off x="457200" y="4892040"/>
             <a:ext cx="8229600" cy="27432"/>
           </a:xfrm>
           <a:prstGeom prst="rect">
@@ -2152,7 +2152,7 @@
         </p:nvSpPr>
         <p:spPr>
           <a:xfrm>
-            <a:off x="1260043" y="4983480"/>
+            <a:off x="457200" y="4983480"/>
             <a:ext cx="8229600" cy="182880"/>
           </a:xfrm>
           <a:prstGeom prst="rect">
@@ -2188,7 +2188,7 @@
         </p:nvSpPr>
         <p:spPr>
           <a:xfrm>
-            <a:off x="1260043" y="137160"/>
+            <a:off x="457200" y="137160"/>
             <a:ext cx="8229600" cy="365760"/>
           </a:xfrm>
           <a:prstGeom prst="rect">
@@ -2227,7 +2227,7 @@
         </p:nvSpPr>
         <p:spPr>
           <a:xfrm>
-            <a:off x="1260043" y="502920"/>
+            <a:off x="457200" y="502920"/>
             <a:ext cx="914400" cy="27432"/>
           </a:xfrm>
           <a:prstGeom prst="rect">
@@ -2247,7 +2247,7 @@
         </p:nvSpPr>
         <p:spPr>
           <a:xfrm>
-            <a:off x="1260043" y="685800"/>
+            <a:off x="457200" y="685800"/>
             <a:ext cx="1325880" cy="530352"/>
           </a:xfrm>
           <a:prstGeom prst="roundRect">
@@ -2274,7 +2274,7 @@
         </p:nvSpPr>
         <p:spPr>
           <a:xfrm>
-            <a:off x="1260043" y="694944"/>
+            <a:off x="457200" y="694944"/>
             <a:ext cx="1325880" cy="164592"/>
           </a:xfrm>
           <a:prstGeom prst="rect">
@@ -2313,7 +2313,7 @@
         </p:nvSpPr>
         <p:spPr>
           <a:xfrm>
-            <a:off x="1260043" y="850392"/>
+            <a:off x="457200" y="850392"/>
             <a:ext cx="1325880" cy="164592"/>
           </a:xfrm>
           <a:prstGeom prst="rect">
@@ -2352,7 +2352,7 @@
         </p:nvSpPr>
         <p:spPr>
           <a:xfrm>
-            <a:off x="1260043" y="1005840"/>
+            <a:off x="457200" y="1005840"/>
             <a:ext cx="1325880" cy="146304"/>
           </a:xfrm>
           <a:prstGeom prst="rect">
@@ -2388,7 +2388,7 @@
         </p:nvSpPr>
         <p:spPr>
           <a:xfrm>
-            <a:off x="2640787" y="685800"/>
+            <a:off x="1837944" y="685800"/>
             <a:ext cx="1325880" cy="530352"/>
           </a:xfrm>
           <a:prstGeom prst="roundRect">
@@ -2415,7 +2415,7 @@
         </p:nvSpPr>
         <p:spPr>
           <a:xfrm>
-            <a:off x="2640787" y="694944"/>
+            <a:off x="1837944" y="694944"/>
             <a:ext cx="1325880" cy="164592"/>
           </a:xfrm>
           <a:prstGeom prst="rect">
@@ -2454,7 +2454,7 @@
         </p:nvSpPr>
         <p:spPr>
           <a:xfrm>
-            <a:off x="2640787" y="850392"/>
+            <a:off x="1837944" y="850392"/>
             <a:ext cx="1325880" cy="164592"/>
           </a:xfrm>
           <a:prstGeom prst="rect">
@@ -2493,7 +2493,7 @@
         </p:nvSpPr>
         <p:spPr>
           <a:xfrm>
-            <a:off x="2640787" y="1005840"/>
+            <a:off x="1837944" y="1005840"/>
             <a:ext cx="1325880" cy="146304"/>
           </a:xfrm>
           <a:prstGeom prst="rect">
@@ -2529,7 +2529,7 @@
         </p:nvSpPr>
         <p:spPr>
           <a:xfrm>
-            <a:off x="4021531" y="685800"/>
+            <a:off x="3218688" y="685800"/>
             <a:ext cx="1325880" cy="530352"/>
           </a:xfrm>
           <a:prstGeom prst="roundRect">
@@ -2556,7 +2556,7 @@
         </p:nvSpPr>
         <p:spPr>
           <a:xfrm>
-            <a:off x="4021531" y="694944"/>
+            <a:off x="3218688" y="694944"/>
             <a:ext cx="1325880" cy="164592"/>
           </a:xfrm>
           <a:prstGeom prst="rect">
@@ -2595,7 +2595,7 @@
         </p:nvSpPr>
         <p:spPr>
           <a:xfrm>
-            <a:off x="4021531" y="850392"/>
+            <a:off x="3218688" y="850392"/>
             <a:ext cx="1325880" cy="164592"/>
           </a:xfrm>
           <a:prstGeom prst="rect">
@@ -2634,7 +2634,7 @@
         </p:nvSpPr>
         <p:spPr>
           <a:xfrm>
-            <a:off x="4021531" y="1005840"/>
+            <a:off x="3218688" y="1005840"/>
             <a:ext cx="1325880" cy="146304"/>
           </a:xfrm>
           <a:prstGeom prst="rect">
@@ -2670,7 +2670,7 @@
         </p:nvSpPr>
         <p:spPr>
           <a:xfrm>
-            <a:off x="5402275" y="685800"/>
+            <a:off x="4599432" y="685800"/>
             <a:ext cx="1325880" cy="530352"/>
           </a:xfrm>
           <a:prstGeom prst="roundRect">
@@ -2697,7 +2697,7 @@
         </p:nvSpPr>
         <p:spPr>
           <a:xfrm>
-            <a:off x="5402275" y="694944"/>
+            <a:off x="4599432" y="694944"/>
             <a:ext cx="1325880" cy="164592"/>
           </a:xfrm>
           <a:prstGeom prst="rect">
@@ -2736,7 +2736,7 @@
         </p:nvSpPr>
         <p:spPr>
           <a:xfrm>
-            <a:off x="5402275" y="850392"/>
+            <a:off x="4599432" y="850392"/>
             <a:ext cx="1325880" cy="164592"/>
           </a:xfrm>
           <a:prstGeom prst="rect">
@@ -2775,7 +2775,7 @@
         </p:nvSpPr>
         <p:spPr>
           <a:xfrm>
-            <a:off x="5402275" y="1005840"/>
+            <a:off x="4599432" y="1005840"/>
             <a:ext cx="1325880" cy="146304"/>
           </a:xfrm>
           <a:prstGeom prst="rect">
@@ -2811,7 +2811,7 @@
         </p:nvSpPr>
         <p:spPr>
           <a:xfrm>
-            <a:off x="6783019" y="685800"/>
+            <a:off x="5980176" y="685800"/>
             <a:ext cx="1325880" cy="530352"/>
           </a:xfrm>
           <a:prstGeom prst="roundRect">
@@ -2838,7 +2838,7 @@
         </p:nvSpPr>
         <p:spPr>
           <a:xfrm>
-            <a:off x="6783019" y="694944"/>
+            <a:off x="5980176" y="694944"/>
             <a:ext cx="1325880" cy="164592"/>
           </a:xfrm>
           <a:prstGeom prst="rect">
@@ -2877,7 +2877,7 @@
         </p:nvSpPr>
         <p:spPr>
           <a:xfrm>
-            <a:off x="6783019" y="850392"/>
+            <a:off x="5980176" y="850392"/>
             <a:ext cx="1325880" cy="164592"/>
           </a:xfrm>
           <a:prstGeom prst="rect">
@@ -2916,7 +2916,7 @@
         </p:nvSpPr>
         <p:spPr>
           <a:xfrm>
-            <a:off x="6783019" y="1005840"/>
+            <a:off x="5980176" y="1005840"/>
             <a:ext cx="1325880" cy="146304"/>
           </a:xfrm>
           <a:prstGeom prst="rect">
@@ -2952,7 +2952,7 @@
         </p:nvSpPr>
         <p:spPr>
           <a:xfrm>
-            <a:off x="8163763" y="685800"/>
+            <a:off x="7360920" y="685800"/>
             <a:ext cx="1325880" cy="530352"/>
           </a:xfrm>
           <a:prstGeom prst="roundRect">
@@ -2979,7 +2979,7 @@
         </p:nvSpPr>
         <p:spPr>
           <a:xfrm>
-            <a:off x="8163763" y="694944"/>
+            <a:off x="7360920" y="694944"/>
             <a:ext cx="1325880" cy="164592"/>
           </a:xfrm>
           <a:prstGeom prst="rect">
@@ -3018,7 +3018,7 @@
         </p:nvSpPr>
         <p:spPr>
           <a:xfrm>
-            <a:off x="8163763" y="850392"/>
+            <a:off x="7360920" y="850392"/>
             <a:ext cx="1325880" cy="164592"/>
           </a:xfrm>
           <a:prstGeom prst="rect">
@@ -3057,7 +3057,7 @@
         </p:nvSpPr>
         <p:spPr>
           <a:xfrm>
-            <a:off x="8163763" y="1005840"/>
+            <a:off x="7360920" y="1005840"/>
             <a:ext cx="1325880" cy="146304"/>
           </a:xfrm>
           <a:prstGeom prst="rect">
@@ -3093,7 +3093,7 @@
         </p:nvSpPr>
         <p:spPr>
           <a:xfrm>
-            <a:off x="1260043" y="1371600"/>
+            <a:off x="457200" y="1371600"/>
             <a:ext cx="4046220" cy="182880"/>
           </a:xfrm>
           <a:prstGeom prst="rect">
@@ -3129,7 +3129,7 @@
         </p:nvSpPr>
         <p:spPr>
           <a:xfrm>
-            <a:off x="1260043" y="1600200"/>
+            <a:off x="457200" y="1600200"/>
             <a:ext cx="4046220" cy="411480"/>
           </a:xfrm>
           <a:prstGeom prst="roundRect">
@@ -3156,7 +3156,7 @@
         </p:nvSpPr>
         <p:spPr>
           <a:xfrm>
-            <a:off x="1260043" y="1600200"/>
+            <a:off x="457200" y="1600200"/>
             <a:ext cx="4046220" cy="411480"/>
           </a:xfrm>
           <a:prstGeom prst="rect">
@@ -3206,7 +3206,7 @@
         </p:nvSpPr>
         <p:spPr>
           <a:xfrm>
-            <a:off x="5443423" y="1600200"/>
+            <a:off x="4640580" y="1600200"/>
             <a:ext cx="4046220" cy="411480"/>
           </a:xfrm>
           <a:prstGeom prst="roundRect">
@@ -3233,7 +3233,7 @@
         </p:nvSpPr>
         <p:spPr>
           <a:xfrm>
-            <a:off x="5443423" y="1600200"/>
+            <a:off x="4640580" y="1600200"/>
             <a:ext cx="4046220" cy="411480"/>
           </a:xfrm>
           <a:prstGeom prst="rect">
@@ -3283,7 +3283,7 @@
         </p:nvSpPr>
         <p:spPr>
           <a:xfrm>
-            <a:off x="1260043" y="2148840"/>
+            <a:off x="457200" y="2148840"/>
             <a:ext cx="4046220" cy="182880"/>
           </a:xfrm>
           <a:prstGeom prst="rect">
@@ -3319,7 +3319,7 @@
         </p:nvSpPr>
         <p:spPr>
           <a:xfrm>
-            <a:off x="1260043" y="2377440"/>
+            <a:off x="457200" y="2377440"/>
             <a:ext cx="4046220" cy="411480"/>
           </a:xfrm>
           <a:prstGeom prst="roundRect">
@@ -3346,7 +3346,7 @@
         </p:nvSpPr>
         <p:spPr>
           <a:xfrm>
-            <a:off x="1260043" y="2377440"/>
+            <a:off x="457200" y="2377440"/>
             <a:ext cx="4046220" cy="411480"/>
           </a:xfrm>
           <a:prstGeom prst="rect">
@@ -3396,7 +3396,7 @@
         </p:nvSpPr>
         <p:spPr>
           <a:xfrm>
-            <a:off x="5443423" y="2377440"/>
+            <a:off x="4640580" y="2377440"/>
             <a:ext cx="4046220" cy="411480"/>
           </a:xfrm>
           <a:prstGeom prst="roundRect">
@@ -3423,7 +3423,7 @@
         </p:nvSpPr>
         <p:spPr>
           <a:xfrm>
-            <a:off x="5443423" y="2377440"/>
+            <a:off x="4640580" y="2377440"/>
             <a:ext cx="4046220" cy="411480"/>
           </a:xfrm>
           <a:prstGeom prst="rect">
@@ -3480,7 +3480,7 @@
           </p:nvPr>
         </p:nvGraphicFramePr>
         <p:xfrm>
-          <a:off x="1260043" y="2926080"/>
+          <a:off x="457200" y="2926080"/>
           <a:ext cx="8229600" cy="914400"/>
         </p:xfrm>
         <a:graphic>
@@ -4487,7 +4487,7 @@
         </p:nvSpPr>
         <p:spPr>
           <a:xfrm>
-            <a:off x="1260043" y="4251960"/>
+            <a:off x="457200" y="4251960"/>
             <a:ext cx="8229600" cy="164592"/>
           </a:xfrm>
           <a:prstGeom prst="rect">
@@ -4555,7 +4555,7 @@
         </p:nvSpPr>
         <p:spPr>
           <a:xfrm>
-            <a:off x="1260043" y="4892040"/>
+            <a:off x="457200" y="4892040"/>
             <a:ext cx="8229600" cy="27432"/>
           </a:xfrm>
           <a:prstGeom prst="rect">
@@ -4575,7 +4575,7 @@
         </p:nvSpPr>
         <p:spPr>
           <a:xfrm>
-            <a:off x="1260043" y="4983480"/>
+            <a:off x="457200" y="4983480"/>
             <a:ext cx="8229600" cy="182880"/>
           </a:xfrm>
           <a:prstGeom prst="rect">
@@ -4611,7 +4611,7 @@
         </p:nvSpPr>
         <p:spPr>
           <a:xfrm>
-            <a:off x="1260043" y="137160"/>
+            <a:off x="457200" y="137160"/>
             <a:ext cx="8229600" cy="365760"/>
           </a:xfrm>
           <a:prstGeom prst="rect">
@@ -4650,7 +4650,7 @@
         </p:nvSpPr>
         <p:spPr>
           <a:xfrm>
-            <a:off x="1260043" y="502920"/>
+            <a:off x="457200" y="502920"/>
             <a:ext cx="914400" cy="27432"/>
           </a:xfrm>
           <a:prstGeom prst="rect">
@@ -4670,7 +4670,7 @@
         </p:nvSpPr>
         <p:spPr>
           <a:xfrm>
-            <a:off x="1260043" y="658368"/>
+            <a:off x="457200" y="658368"/>
             <a:ext cx="4572000" cy="164592"/>
           </a:xfrm>
           <a:prstGeom prst="rect">
@@ -4713,7 +4713,7 @@
           </p:nvPr>
         </p:nvGraphicFramePr>
         <p:xfrm>
-          <a:off x="1260043" y="868680"/>
+          <a:off x="457200" y="868680"/>
           <a:ext cx="8229600" cy="914400"/>
         </p:xfrm>
         <a:graphic>
@@ -5720,7 +5720,7 @@
         </p:nvSpPr>
         <p:spPr>
           <a:xfrm>
-            <a:off x="1260043" y="2194560"/>
+            <a:off x="457200" y="2194560"/>
             <a:ext cx="4572000" cy="164592"/>
           </a:xfrm>
           <a:prstGeom prst="rect">
@@ -5763,7 +5763,7 @@
           </p:nvPr>
         </p:nvGraphicFramePr>
         <p:xfrm>
-          <a:off x="1260043" y="2404872"/>
+          <a:off x="457200" y="2404872"/>
           <a:ext cx="8229600" cy="914400"/>
         </p:xfrm>
         <a:graphic>
@@ -7194,7 +7194,7 @@
         </p:nvSpPr>
         <p:spPr>
           <a:xfrm>
-            <a:off x="1260043" y="4892040"/>
+            <a:off x="457200" y="4892040"/>
             <a:ext cx="8229600" cy="27432"/>
           </a:xfrm>
           <a:prstGeom prst="rect">
@@ -7214,7 +7214,7 @@
         </p:nvSpPr>
         <p:spPr>
           <a:xfrm>
-            <a:off x="1260043" y="4983480"/>
+            <a:off x="457200" y="4983480"/>
             <a:ext cx="8229600" cy="182880"/>
           </a:xfrm>
           <a:prstGeom prst="rect">
@@ -7250,7 +7250,7 @@
         </p:nvSpPr>
         <p:spPr>
           <a:xfrm>
-            <a:off x="1260043" y="137160"/>
+            <a:off x="457200" y="137160"/>
             <a:ext cx="8229600" cy="365760"/>
           </a:xfrm>
           <a:prstGeom prst="rect">
@@ -7289,7 +7289,7 @@
         </p:nvSpPr>
         <p:spPr>
           <a:xfrm>
-            <a:off x="1260043" y="502920"/>
+            <a:off x="457200" y="502920"/>
             <a:ext cx="914400" cy="27432"/>
           </a:xfrm>
           <a:prstGeom prst="rect">
@@ -7309,7 +7309,7 @@
         </p:nvSpPr>
         <p:spPr>
           <a:xfrm>
-            <a:off x="1260043" y="658368"/>
+            <a:off x="457200" y="658368"/>
             <a:ext cx="4572000" cy="164592"/>
           </a:xfrm>
           <a:prstGeom prst="rect">
@@ -7352,7 +7352,7 @@
           </p:nvPr>
         </p:nvGraphicFramePr>
         <p:xfrm>
-          <a:off x="1260043" y="868680"/>
+          <a:off x="457200" y="868680"/>
           <a:ext cx="8229600" cy="914400"/>
         </p:xfrm>
         <a:graphic>
@@ -8162,7 +8162,7 @@
         </p:nvSpPr>
         <p:spPr>
           <a:xfrm>
-            <a:off x="1260043" y="1965960"/>
+            <a:off x="457200" y="1965960"/>
             <a:ext cx="4572000" cy="164592"/>
           </a:xfrm>
           <a:prstGeom prst="rect">
@@ -8205,7 +8205,7 @@
           </p:nvPr>
         </p:nvGraphicFramePr>
         <p:xfrm>
-          <a:off x="1260043" y="2176272"/>
+          <a:off x="457200" y="2176272"/>
           <a:ext cx="8229600" cy="914400"/>
         </p:xfrm>
         <a:graphic>
@@ -9650,7 +9650,7 @@
         </p:nvSpPr>
         <p:spPr>
           <a:xfrm>
-            <a:off x="1260043" y="4892040"/>
+            <a:off x="457200" y="4892040"/>
             <a:ext cx="8229600" cy="27432"/>
           </a:xfrm>
           <a:prstGeom prst="rect">
@@ -9670,7 +9670,7 @@
         </p:nvSpPr>
         <p:spPr>
           <a:xfrm>
-            <a:off x="1260043" y="4983480"/>
+            <a:off x="457200" y="4983480"/>
             <a:ext cx="8229600" cy="182880"/>
           </a:xfrm>
           <a:prstGeom prst="rect">
@@ -9706,7 +9706,7 @@
         </p:nvSpPr>
         <p:spPr>
           <a:xfrm>
-            <a:off x="1260043" y="137160"/>
+            <a:off x="457200" y="137160"/>
             <a:ext cx="8229600" cy="365760"/>
           </a:xfrm>
           <a:prstGeom prst="rect">
@@ -9745,7 +9745,7 @@
         </p:nvSpPr>
         <p:spPr>
           <a:xfrm>
-            <a:off x="1260043" y="502920"/>
+            <a:off x="457200" y="502920"/>
             <a:ext cx="914400" cy="27432"/>
           </a:xfrm>
           <a:prstGeom prst="rect">
@@ -9765,7 +9765,7 @@
         </p:nvSpPr>
         <p:spPr>
           <a:xfrm>
-            <a:off x="1260043" y="658368"/>
+            <a:off x="457200" y="658368"/>
             <a:ext cx="2670048" cy="777240"/>
           </a:xfrm>
           <a:prstGeom prst="roundRect">
@@ -9792,7 +9792,7 @@
         </p:nvSpPr>
         <p:spPr>
           <a:xfrm>
-            <a:off x="1333195" y="685800"/>
+            <a:off x="530352" y="685800"/>
             <a:ext cx="2523744" cy="182880"/>
           </a:xfrm>
           <a:prstGeom prst="rect">
@@ -9831,7 +9831,7 @@
         </p:nvSpPr>
         <p:spPr>
           <a:xfrm>
-            <a:off x="1333195" y="868680"/>
+            <a:off x="530352" y="868680"/>
             <a:ext cx="2523744" cy="539496"/>
           </a:xfrm>
           <a:prstGeom prst="rect">
@@ -9887,7 +9887,7 @@
         </p:nvSpPr>
         <p:spPr>
           <a:xfrm>
-            <a:off x="4039819" y="658368"/>
+            <a:off x="3236976" y="658368"/>
             <a:ext cx="2670048" cy="777240"/>
           </a:xfrm>
           <a:prstGeom prst="roundRect">
@@ -9914,7 +9914,7 @@
         </p:nvSpPr>
         <p:spPr>
           <a:xfrm>
-            <a:off x="4112971" y="685800"/>
+            <a:off x="3310128" y="685800"/>
             <a:ext cx="2523744" cy="182880"/>
           </a:xfrm>
           <a:prstGeom prst="rect">
@@ -9953,7 +9953,7 @@
         </p:nvSpPr>
         <p:spPr>
           <a:xfrm>
-            <a:off x="4112971" y="868680"/>
+            <a:off x="3310128" y="868680"/>
             <a:ext cx="2523744" cy="539496"/>
           </a:xfrm>
           <a:prstGeom prst="rect">
@@ -10009,7 +10009,7 @@
         </p:nvSpPr>
         <p:spPr>
           <a:xfrm>
-            <a:off x="6819595" y="658368"/>
+            <a:off x="6016752" y="658368"/>
             <a:ext cx="2670048" cy="777240"/>
           </a:xfrm>
           <a:prstGeom prst="roundRect">
@@ -10036,7 +10036,7 @@
         </p:nvSpPr>
         <p:spPr>
           <a:xfrm>
-            <a:off x="6892747" y="685800"/>
+            <a:off x="6089904" y="685800"/>
             <a:ext cx="2523744" cy="182880"/>
           </a:xfrm>
           <a:prstGeom prst="rect">
@@ -10075,7 +10075,7 @@
         </p:nvSpPr>
         <p:spPr>
           <a:xfrm>
-            <a:off x="6892747" y="868680"/>
+            <a:off x="6089904" y="868680"/>
             <a:ext cx="2523744" cy="539496"/>
           </a:xfrm>
           <a:prstGeom prst="rect">
@@ -10131,7 +10131,7 @@
         </p:nvSpPr>
         <p:spPr>
           <a:xfrm>
-            <a:off x="1260043" y="1527048"/>
+            <a:off x="457200" y="1527048"/>
             <a:ext cx="2670048" cy="777240"/>
           </a:xfrm>
           <a:prstGeom prst="roundRect">
@@ -10158,7 +10158,7 @@
         </p:nvSpPr>
         <p:spPr>
           <a:xfrm>
-            <a:off x="1333195" y="1554480"/>
+            <a:off x="530352" y="1554480"/>
             <a:ext cx="2523744" cy="182880"/>
           </a:xfrm>
           <a:prstGeom prst="rect">
@@ -10197,7 +10197,7 @@
         </p:nvSpPr>
         <p:spPr>
           <a:xfrm>
-            <a:off x="1333195" y="1737360"/>
+            <a:off x="530352" y="1737360"/>
             <a:ext cx="2523744" cy="539496"/>
           </a:xfrm>
           <a:prstGeom prst="rect">
@@ -10253,7 +10253,7 @@
         </p:nvSpPr>
         <p:spPr>
           <a:xfrm>
-            <a:off x="4039819" y="1527048"/>
+            <a:off x="3236976" y="1527048"/>
             <a:ext cx="2670048" cy="777240"/>
           </a:xfrm>
           <a:prstGeom prst="roundRect">
@@ -10280,7 +10280,7 @@
         </p:nvSpPr>
         <p:spPr>
           <a:xfrm>
-            <a:off x="4112971" y="1554480"/>
+            <a:off x="3310128" y="1554480"/>
             <a:ext cx="2523744" cy="182880"/>
           </a:xfrm>
           <a:prstGeom prst="rect">
@@ -10319,7 +10319,7 @@
         </p:nvSpPr>
         <p:spPr>
           <a:xfrm>
-            <a:off x="4112971" y="1737360"/>
+            <a:off x="3310128" y="1737360"/>
             <a:ext cx="2523744" cy="539496"/>
           </a:xfrm>
           <a:prstGeom prst="rect">
@@ -10375,7 +10375,7 @@
         </p:nvSpPr>
         <p:spPr>
           <a:xfrm>
-            <a:off x="6819595" y="1527048"/>
+            <a:off x="6016752" y="1527048"/>
             <a:ext cx="2670048" cy="777240"/>
           </a:xfrm>
           <a:prstGeom prst="roundRect">
@@ -10402,7 +10402,7 @@
         </p:nvSpPr>
         <p:spPr>
           <a:xfrm>
-            <a:off x="6892747" y="1554480"/>
+            <a:off x="6089904" y="1554480"/>
             <a:ext cx="2523744" cy="182880"/>
           </a:xfrm>
           <a:prstGeom prst="rect">
@@ -10441,7 +10441,7 @@
         </p:nvSpPr>
         <p:spPr>
           <a:xfrm>
-            <a:off x="6892747" y="1737360"/>
+            <a:off x="6089904" y="1737360"/>
             <a:ext cx="2523744" cy="539496"/>
           </a:xfrm>
           <a:prstGeom prst="rect">
@@ -10497,7 +10497,7 @@
         </p:nvSpPr>
         <p:spPr>
           <a:xfrm>
-            <a:off x="1260043" y="2395728"/>
+            <a:off x="457200" y="2395728"/>
             <a:ext cx="4046220" cy="164592"/>
           </a:xfrm>
           <a:prstGeom prst="rect">
@@ -10540,7 +10540,7 @@
           </p:nvPr>
         </p:nvGraphicFramePr>
         <p:xfrm>
-          <a:off x="1260043" y="2596896"/>
+          <a:off x="457200" y="2596896"/>
           <a:ext cx="4046220" cy="914400"/>
         </p:xfrm>
         <a:graphic>
@@ -12346,7 +12346,7 @@
         </p:nvSpPr>
         <p:spPr>
           <a:xfrm>
-            <a:off x="5443423" y="2395728"/>
+            <a:off x="4640580" y="2395728"/>
             <a:ext cx="4046220" cy="164592"/>
           </a:xfrm>
           <a:prstGeom prst="rect">
@@ -12382,7 +12382,7 @@
         </p:nvSpPr>
         <p:spPr>
           <a:xfrm>
-            <a:off x="5443423" y="2596896"/>
+            <a:off x="4640580" y="2596896"/>
             <a:ext cx="4046220" cy="310896"/>
           </a:xfrm>
           <a:prstGeom prst="roundRect">
@@ -12409,7 +12409,7 @@
         </p:nvSpPr>
         <p:spPr>
           <a:xfrm>
-            <a:off x="5516575" y="2624328"/>
+            <a:off x="4713732" y="2624328"/>
             <a:ext cx="3899916" cy="182880"/>
           </a:xfrm>
           <a:prstGeom prst="rect">
@@ -12448,7 +12448,7 @@
         </p:nvSpPr>
         <p:spPr>
           <a:xfrm>
-            <a:off x="5516575" y="2807208"/>
+            <a:off x="4713732" y="2807208"/>
             <a:ext cx="3899916" cy="73152"/>
           </a:xfrm>
           <a:prstGeom prst="rect">
@@ -12487,7 +12487,7 @@
         </p:nvSpPr>
         <p:spPr>
           <a:xfrm>
-            <a:off x="5443423" y="2944368"/>
+            <a:off x="4640580" y="2944368"/>
             <a:ext cx="4046220" cy="310896"/>
           </a:xfrm>
           <a:prstGeom prst="roundRect">
@@ -12514,7 +12514,7 @@
         </p:nvSpPr>
         <p:spPr>
           <a:xfrm>
-            <a:off x="5516575" y="2971800"/>
+            <a:off x="4713732" y="2971800"/>
             <a:ext cx="3899916" cy="182880"/>
           </a:xfrm>
           <a:prstGeom prst="rect">
@@ -12553,7 +12553,7 @@
         </p:nvSpPr>
         <p:spPr>
           <a:xfrm>
-            <a:off x="5516575" y="3154680"/>
+            <a:off x="4713732" y="3154680"/>
             <a:ext cx="3899916" cy="73152"/>
           </a:xfrm>
           <a:prstGeom prst="rect">
@@ -12592,7 +12592,7 @@
         </p:nvSpPr>
         <p:spPr>
           <a:xfrm>
-            <a:off x="5443423" y="3291840"/>
+            <a:off x="4640580" y="3291840"/>
             <a:ext cx="4046220" cy="310896"/>
           </a:xfrm>
           <a:prstGeom prst="roundRect">
@@ -12619,7 +12619,7 @@
         </p:nvSpPr>
         <p:spPr>
           <a:xfrm>
-            <a:off x="5516575" y="3319272"/>
+            <a:off x="4713732" y="3319272"/>
             <a:ext cx="3899916" cy="182880"/>
           </a:xfrm>
           <a:prstGeom prst="rect">
@@ -12658,7 +12658,7 @@
         </p:nvSpPr>
         <p:spPr>
           <a:xfrm>
-            <a:off x="5516575" y="3502152"/>
+            <a:off x="4713732" y="3502152"/>
             <a:ext cx="3899916" cy="73152"/>
           </a:xfrm>
           <a:prstGeom prst="rect">
@@ -12729,7 +12729,7 @@
         </p:nvSpPr>
         <p:spPr>
           <a:xfrm>
-            <a:off x="1260043" y="4892040"/>
+            <a:off x="457200" y="4892040"/>
             <a:ext cx="8229600" cy="27432"/>
           </a:xfrm>
           <a:prstGeom prst="rect">
@@ -12749,7 +12749,7 @@
         </p:nvSpPr>
         <p:spPr>
           <a:xfrm>
-            <a:off x="1260043" y="4983480"/>
+            <a:off x="457200" y="4983480"/>
             <a:ext cx="8229600" cy="182880"/>
           </a:xfrm>
           <a:prstGeom prst="rect">
@@ -12785,7 +12785,7 @@
         </p:nvSpPr>
         <p:spPr>
           <a:xfrm>
-            <a:off x="1260043" y="137160"/>
+            <a:off x="457200" y="137160"/>
             <a:ext cx="8229600" cy="365760"/>
           </a:xfrm>
           <a:prstGeom prst="rect">
@@ -12824,7 +12824,7 @@
         </p:nvSpPr>
         <p:spPr>
           <a:xfrm>
-            <a:off x="1260043" y="502920"/>
+            <a:off x="457200" y="502920"/>
             <a:ext cx="914400" cy="27432"/>
           </a:xfrm>
           <a:prstGeom prst="rect">
@@ -12844,7 +12844,7 @@
         </p:nvSpPr>
         <p:spPr>
           <a:xfrm>
-            <a:off x="1260043" y="658368"/>
+            <a:off x="457200" y="658368"/>
             <a:ext cx="4023360" cy="164592"/>
           </a:xfrm>
           <a:prstGeom prst="rect">
@@ -12887,7 +12887,7 @@
           </p:nvPr>
         </p:nvGraphicFramePr>
         <p:xfrm>
-          <a:off x="1260043" y="868680"/>
+          <a:off x="457200" y="868680"/>
           <a:ext cx="4023360" cy="914400"/>
         </p:xfrm>
         <a:graphic>
@@ -15302,7 +15302,7 @@
         </p:nvSpPr>
         <p:spPr>
           <a:xfrm>
-            <a:off x="5466283" y="658368"/>
+            <a:off x="4663440" y="658368"/>
             <a:ext cx="4023360" cy="164592"/>
           </a:xfrm>
           <a:prstGeom prst="rect">
@@ -15345,7 +15345,7 @@
           </p:nvPr>
         </p:nvGraphicFramePr>
         <p:xfrm>
-          <a:off x="5466283" y="868680"/>
+          <a:off x="4663440" y="868680"/>
           <a:ext cx="4023360" cy="914400"/>
         </p:xfrm>
         <a:graphic>
@@ -17566,7 +17566,7 @@
         </p:nvSpPr>
         <p:spPr>
           <a:xfrm>
-            <a:off x="1260043" y="2880360"/>
+            <a:off x="457200" y="2880360"/>
             <a:ext cx="8229600" cy="164592"/>
           </a:xfrm>
           <a:prstGeom prst="rect">
@@ -17609,7 +17609,7 @@
           </p:nvPr>
         </p:nvGraphicFramePr>
         <p:xfrm>
-          <a:off x="1260043" y="3063240"/>
+          <a:off x="457200" y="3063240"/>
           <a:ext cx="8229600" cy="914400"/>
         </p:xfrm>
         <a:graphic>
@@ -18694,7 +18694,7 @@
         </p:nvSpPr>
         <p:spPr>
           <a:xfrm>
-            <a:off x="1260043" y="4069080"/>
+            <a:off x="457200" y="4069080"/>
             <a:ext cx="8229600" cy="256032"/>
           </a:xfrm>
           <a:prstGeom prst="roundRect">
@@ -18721,7 +18721,7 @@
         </p:nvSpPr>
         <p:spPr>
           <a:xfrm>
-            <a:off x="1397203" y="4078224"/>
+            <a:off x="594360" y="4078224"/>
             <a:ext cx="7955280" cy="237744"/>
           </a:xfrm>
           <a:prstGeom prst="rect">

</xml_diff>

<commit_message>
fix: PPT向下伸展~1cm — 底栏5.35→5.48, 表行高+15%, 卡片+0.1"
</commit_message>
<xml_diff>
--- a/docs/AI-Native-训战营-介绍与日程.pptx
+++ b/docs/AI-Native-训战营-介绍与日程.pptx
@@ -1328,7 +1328,7 @@
         </p:nvSpPr>
         <p:spPr>
           <a:xfrm>
-            <a:off x="457200" y="4892040"/>
+            <a:off x="457200" y="5010912"/>
             <a:ext cx="8229600" cy="27432"/>
           </a:xfrm>
           <a:prstGeom prst="rect">
@@ -1348,7 +1348,7 @@
         </p:nvSpPr>
         <p:spPr>
           <a:xfrm>
-            <a:off x="457200" y="4983480"/>
+            <a:off x="457200" y="5084064"/>
             <a:ext cx="8229600" cy="182880"/>
           </a:xfrm>
           <a:prstGeom prst="rect">
@@ -2132,7 +2132,7 @@
         </p:nvSpPr>
         <p:spPr>
           <a:xfrm>
-            <a:off x="457200" y="4892040"/>
+            <a:off x="457200" y="5010912"/>
             <a:ext cx="8229600" cy="27432"/>
           </a:xfrm>
           <a:prstGeom prst="rect">
@@ -2152,7 +2152,7 @@
         </p:nvSpPr>
         <p:spPr>
           <a:xfrm>
-            <a:off x="457200" y="4983480"/>
+            <a:off x="457200" y="5084064"/>
             <a:ext cx="8229600" cy="182880"/>
           </a:xfrm>
           <a:prstGeom prst="rect">
@@ -3687,7 +3687,7 @@
                   </a:tcPr>
                 </a:tc>
               </a:tr>
-              <a:tr h="219456">
+              <a:tr h="256032">
                 <a:tc>
                   <a:txBody>
                     <a:bodyPr/>
@@ -3884,7 +3884,7 @@
                   </a:tcPr>
                 </a:tc>
               </a:tr>
-              <a:tr h="219456">
+              <a:tr h="256032">
                 <a:tc>
                   <a:txBody>
                     <a:bodyPr/>
@@ -4081,7 +4081,7 @@
                   </a:tcPr>
                 </a:tc>
               </a:tr>
-              <a:tr h="219456">
+              <a:tr h="256032">
                 <a:tc>
                   <a:txBody>
                     <a:bodyPr/>
@@ -4278,7 +4278,7 @@
                   </a:tcPr>
                 </a:tc>
               </a:tr>
-              <a:tr h="219456">
+              <a:tr h="256032">
                 <a:tc>
                   <a:txBody>
                     <a:bodyPr/>
@@ -4487,7 +4487,7 @@
         </p:nvSpPr>
         <p:spPr>
           <a:xfrm>
-            <a:off x="457200" y="4251960"/>
+            <a:off x="457200" y="4389120"/>
             <a:ext cx="8229600" cy="164592"/>
           </a:xfrm>
           <a:prstGeom prst="rect">
@@ -4555,7 +4555,7 @@
         </p:nvSpPr>
         <p:spPr>
           <a:xfrm>
-            <a:off x="457200" y="4892040"/>
+            <a:off x="457200" y="5010912"/>
             <a:ext cx="8229600" cy="27432"/>
           </a:xfrm>
           <a:prstGeom prst="rect">
@@ -4575,7 +4575,7 @@
         </p:nvSpPr>
         <p:spPr>
           <a:xfrm>
-            <a:off x="457200" y="4983480"/>
+            <a:off x="457200" y="5084064"/>
             <a:ext cx="8229600" cy="182880"/>
           </a:xfrm>
           <a:prstGeom prst="rect">
@@ -4931,7 +4931,7 @@
                   </a:tcPr>
                 </a:tc>
               </a:tr>
-              <a:tr h="256032">
+              <a:tr h="292608">
                 <a:tc>
                   <a:txBody>
                     <a:bodyPr/>
@@ -5128,7 +5128,7 @@
                   </a:tcPr>
                 </a:tc>
               </a:tr>
-              <a:tr h="292608">
+              <a:tr h="329184">
                 <a:tc>
                   <a:txBody>
                     <a:bodyPr/>
@@ -5325,7 +5325,7 @@
                   </a:tcPr>
                 </a:tc>
               </a:tr>
-              <a:tr h="146304">
+              <a:tr h="164592">
                 <a:tc>
                   <a:txBody>
                     <a:bodyPr/>
@@ -5511,7 +5511,7 @@
                   </a:tcPr>
                 </a:tc>
               </a:tr>
-              <a:tr h="292608">
+              <a:tr h="329184">
                 <a:tc>
                   <a:txBody>
                     <a:bodyPr/>
@@ -5720,7 +5720,7 @@
         </p:nvSpPr>
         <p:spPr>
           <a:xfrm>
-            <a:off x="457200" y="2194560"/>
+            <a:off x="457200" y="2331720"/>
             <a:ext cx="4572000" cy="164592"/>
           </a:xfrm>
           <a:prstGeom prst="rect">
@@ -5763,7 +5763,7 @@
           </p:nvPr>
         </p:nvGraphicFramePr>
         <p:xfrm>
-          <a:off x="457200" y="2404872"/>
+          <a:off x="457200" y="2560320"/>
           <a:ext cx="8229600" cy="914400"/>
         </p:xfrm>
         <a:graphic>
@@ -5981,7 +5981,7 @@
                   </a:tcPr>
                 </a:tc>
               </a:tr>
-              <a:tr h="274320">
+              <a:tr h="310896">
                 <a:tc>
                   <a:txBody>
                     <a:bodyPr/>
@@ -6181,7 +6181,7 @@
                   </a:tcPr>
                 </a:tc>
               </a:tr>
-              <a:tr h="137160">
+              <a:tr h="155448">
                 <a:tc>
                   <a:txBody>
                     <a:bodyPr/>
@@ -6367,7 +6367,7 @@
                   </a:tcPr>
                 </a:tc>
               </a:tr>
-              <a:tr h="274320">
+              <a:tr h="310896">
                 <a:tc>
                   <a:txBody>
                     <a:bodyPr/>
@@ -6567,7 +6567,7 @@
                   </a:tcPr>
                 </a:tc>
               </a:tr>
-              <a:tr h="137160">
+              <a:tr h="155448">
                 <a:tc>
                   <a:txBody>
                     <a:bodyPr/>
@@ -6753,7 +6753,7 @@
                   </a:tcPr>
                 </a:tc>
               </a:tr>
-              <a:tr h="274320">
+              <a:tr h="310896">
                 <a:tc>
                   <a:txBody>
                     <a:bodyPr/>
@@ -6953,7 +6953,7 @@
                   </a:tcPr>
                 </a:tc>
               </a:tr>
-              <a:tr h="237744">
+              <a:tr h="274320">
                 <a:tc>
                   <a:txBody>
                     <a:bodyPr/>
@@ -7194,7 +7194,7 @@
         </p:nvSpPr>
         <p:spPr>
           <a:xfrm>
-            <a:off x="457200" y="4892040"/>
+            <a:off x="457200" y="5010912"/>
             <a:ext cx="8229600" cy="27432"/>
           </a:xfrm>
           <a:prstGeom prst="rect">
@@ -7214,7 +7214,7 @@
         </p:nvSpPr>
         <p:spPr>
           <a:xfrm>
-            <a:off x="457200" y="4983480"/>
+            <a:off x="457200" y="5084064"/>
             <a:ext cx="8229600" cy="182880"/>
           </a:xfrm>
           <a:prstGeom prst="rect">
@@ -7570,7 +7570,7 @@
                   </a:tcPr>
                 </a:tc>
               </a:tr>
-              <a:tr h="292608">
+              <a:tr h="329184">
                 <a:tc>
                   <a:txBody>
                     <a:bodyPr/>
@@ -7767,7 +7767,7 @@
                   </a:tcPr>
                 </a:tc>
               </a:tr>
-              <a:tr h="146304">
+              <a:tr h="164592">
                 <a:tc>
                   <a:txBody>
                     <a:bodyPr/>
@@ -7953,7 +7953,7 @@
                   </a:tcPr>
                 </a:tc>
               </a:tr>
-              <a:tr h="292608">
+              <a:tr h="329184">
                 <a:tc>
                   <a:txBody>
                     <a:bodyPr/>
@@ -8162,7 +8162,7 @@
         </p:nvSpPr>
         <p:spPr>
           <a:xfrm>
-            <a:off x="457200" y="1965960"/>
+            <a:off x="457200" y="2103120"/>
             <a:ext cx="4572000" cy="164592"/>
           </a:xfrm>
           <a:prstGeom prst="rect">
@@ -8205,7 +8205,7 @@
           </p:nvPr>
         </p:nvGraphicFramePr>
         <p:xfrm>
-          <a:off x="457200" y="2176272"/>
+          <a:off x="457200" y="2331720"/>
           <a:ext cx="8229600" cy="914400"/>
         </p:xfrm>
         <a:graphic>
@@ -8423,7 +8423,7 @@
                   </a:tcPr>
                 </a:tc>
               </a:tr>
-              <a:tr h="274320">
+              <a:tr h="310896">
                 <a:tc>
                   <a:txBody>
                     <a:bodyPr/>
@@ -8623,7 +8623,7 @@
                   </a:tcPr>
                 </a:tc>
               </a:tr>
-              <a:tr h="137160">
+              <a:tr h="155448">
                 <a:tc>
                   <a:txBody>
                     <a:bodyPr/>
@@ -8809,7 +8809,7 @@
                   </a:tcPr>
                 </a:tc>
               </a:tr>
-              <a:tr h="274320">
+              <a:tr h="310896">
                 <a:tc>
                   <a:txBody>
                     <a:bodyPr/>
@@ -9009,7 +9009,7 @@
                   </a:tcPr>
                 </a:tc>
               </a:tr>
-              <a:tr h="237744">
+              <a:tr h="274320">
                 <a:tc>
                   <a:txBody>
                     <a:bodyPr/>
@@ -9209,7 +9209,7 @@
                   </a:tcPr>
                 </a:tc>
               </a:tr>
-              <a:tr h="237744">
+              <a:tr h="274320">
                 <a:tc>
                   <a:txBody>
                     <a:bodyPr/>
@@ -9406,7 +9406,7 @@
                   </a:tcPr>
                 </a:tc>
               </a:tr>
-              <a:tr h="201168">
+              <a:tr h="237744">
                 <a:tc>
                   <a:txBody>
                     <a:bodyPr/>
@@ -9650,7 +9650,7 @@
         </p:nvSpPr>
         <p:spPr>
           <a:xfrm>
-            <a:off x="457200" y="4892040"/>
+            <a:off x="457200" y="5010912"/>
             <a:ext cx="8229600" cy="27432"/>
           </a:xfrm>
           <a:prstGeom prst="rect">
@@ -9670,7 +9670,7 @@
         </p:nvSpPr>
         <p:spPr>
           <a:xfrm>
-            <a:off x="457200" y="4983480"/>
+            <a:off x="457200" y="5084064"/>
             <a:ext cx="8229600" cy="182880"/>
           </a:xfrm>
           <a:prstGeom prst="rect">
@@ -9766,11 +9766,11 @@
         <p:spPr>
           <a:xfrm>
             <a:off x="457200" y="658368"/>
-            <a:ext cx="2670048" cy="777240"/>
+            <a:ext cx="2670048" cy="868680"/>
           </a:xfrm>
           <a:prstGeom prst="roundRect">
             <a:avLst>
-              <a:gd name="adj" fmla="val 9412"/>
+              <a:gd name="adj" fmla="val 8421"/>
             </a:avLst>
           </a:prstGeom>
           <a:solidFill>
@@ -9832,7 +9832,7 @@
         <p:spPr>
           <a:xfrm>
             <a:off x="530352" y="868680"/>
-            <a:ext cx="2523744" cy="539496"/>
+            <a:ext cx="2523744" cy="630936"/>
           </a:xfrm>
           <a:prstGeom prst="rect">
             <a:avLst/>
@@ -9888,11 +9888,11 @@
         <p:spPr>
           <a:xfrm>
             <a:off x="3236976" y="658368"/>
-            <a:ext cx="2670048" cy="777240"/>
+            <a:ext cx="2670048" cy="868680"/>
           </a:xfrm>
           <a:prstGeom prst="roundRect">
             <a:avLst>
-              <a:gd name="adj" fmla="val 9412"/>
+              <a:gd name="adj" fmla="val 8421"/>
             </a:avLst>
           </a:prstGeom>
           <a:solidFill>
@@ -9954,7 +9954,7 @@
         <p:spPr>
           <a:xfrm>
             <a:off x="3310128" y="868680"/>
-            <a:ext cx="2523744" cy="539496"/>
+            <a:ext cx="2523744" cy="630936"/>
           </a:xfrm>
           <a:prstGeom prst="rect">
             <a:avLst/>
@@ -10010,11 +10010,11 @@
         <p:spPr>
           <a:xfrm>
             <a:off x="6016752" y="658368"/>
-            <a:ext cx="2670048" cy="777240"/>
+            <a:ext cx="2670048" cy="868680"/>
           </a:xfrm>
           <a:prstGeom prst="roundRect">
             <a:avLst>
-              <a:gd name="adj" fmla="val 9412"/>
+              <a:gd name="adj" fmla="val 8421"/>
             </a:avLst>
           </a:prstGeom>
           <a:solidFill>
@@ -10076,7 +10076,7 @@
         <p:spPr>
           <a:xfrm>
             <a:off x="6089904" y="868680"/>
-            <a:ext cx="2523744" cy="539496"/>
+            <a:ext cx="2523744" cy="630936"/>
           </a:xfrm>
           <a:prstGeom prst="rect">
             <a:avLst/>
@@ -10131,12 +10131,12 @@
         </p:nvSpPr>
         <p:spPr>
           <a:xfrm>
-            <a:off x="457200" y="1527048"/>
-            <a:ext cx="2670048" cy="777240"/>
+            <a:off x="457200" y="1618488"/>
+            <a:ext cx="2670048" cy="868680"/>
           </a:xfrm>
           <a:prstGeom prst="roundRect">
             <a:avLst>
-              <a:gd name="adj" fmla="val 9412"/>
+              <a:gd name="adj" fmla="val 8421"/>
             </a:avLst>
           </a:prstGeom>
           <a:solidFill>
@@ -10158,7 +10158,7 @@
         </p:nvSpPr>
         <p:spPr>
           <a:xfrm>
-            <a:off x="530352" y="1554480"/>
+            <a:off x="530352" y="1645920"/>
             <a:ext cx="2523744" cy="182880"/>
           </a:xfrm>
           <a:prstGeom prst="rect">
@@ -10197,8 +10197,8 @@
         </p:nvSpPr>
         <p:spPr>
           <a:xfrm>
-            <a:off x="530352" y="1737360"/>
-            <a:ext cx="2523744" cy="539496"/>
+            <a:off x="530352" y="1828800"/>
+            <a:ext cx="2523744" cy="630936"/>
           </a:xfrm>
           <a:prstGeom prst="rect">
             <a:avLst/>
@@ -10253,12 +10253,12 @@
         </p:nvSpPr>
         <p:spPr>
           <a:xfrm>
-            <a:off x="3236976" y="1527048"/>
-            <a:ext cx="2670048" cy="777240"/>
+            <a:off x="3236976" y="1618488"/>
+            <a:ext cx="2670048" cy="868680"/>
           </a:xfrm>
           <a:prstGeom prst="roundRect">
             <a:avLst>
-              <a:gd name="adj" fmla="val 9412"/>
+              <a:gd name="adj" fmla="val 8421"/>
             </a:avLst>
           </a:prstGeom>
           <a:solidFill>
@@ -10280,7 +10280,7 @@
         </p:nvSpPr>
         <p:spPr>
           <a:xfrm>
-            <a:off x="3310128" y="1554480"/>
+            <a:off x="3310128" y="1645920"/>
             <a:ext cx="2523744" cy="182880"/>
           </a:xfrm>
           <a:prstGeom prst="rect">
@@ -10319,8 +10319,8 @@
         </p:nvSpPr>
         <p:spPr>
           <a:xfrm>
-            <a:off x="3310128" y="1737360"/>
-            <a:ext cx="2523744" cy="539496"/>
+            <a:off x="3310128" y="1828800"/>
+            <a:ext cx="2523744" cy="630936"/>
           </a:xfrm>
           <a:prstGeom prst="rect">
             <a:avLst/>
@@ -10375,12 +10375,12 @@
         </p:nvSpPr>
         <p:spPr>
           <a:xfrm>
-            <a:off x="6016752" y="1527048"/>
-            <a:ext cx="2670048" cy="777240"/>
+            <a:off x="6016752" y="1618488"/>
+            <a:ext cx="2670048" cy="868680"/>
           </a:xfrm>
           <a:prstGeom prst="roundRect">
             <a:avLst>
-              <a:gd name="adj" fmla="val 9412"/>
+              <a:gd name="adj" fmla="val 8421"/>
             </a:avLst>
           </a:prstGeom>
           <a:solidFill>
@@ -10402,7 +10402,7 @@
         </p:nvSpPr>
         <p:spPr>
           <a:xfrm>
-            <a:off x="6089904" y="1554480"/>
+            <a:off x="6089904" y="1645920"/>
             <a:ext cx="2523744" cy="182880"/>
           </a:xfrm>
           <a:prstGeom prst="rect">
@@ -10441,8 +10441,8 @@
         </p:nvSpPr>
         <p:spPr>
           <a:xfrm>
-            <a:off x="6089904" y="1737360"/>
-            <a:ext cx="2523744" cy="539496"/>
+            <a:off x="6089904" y="1828800"/>
+            <a:ext cx="2523744" cy="630936"/>
           </a:xfrm>
           <a:prstGeom prst="rect">
             <a:avLst/>
@@ -10497,7 +10497,7 @@
         </p:nvSpPr>
         <p:spPr>
           <a:xfrm>
-            <a:off x="457200" y="2395728"/>
+            <a:off x="457200" y="2578608"/>
             <a:ext cx="4046220" cy="164592"/>
           </a:xfrm>
           <a:prstGeom prst="rect">
@@ -10540,7 +10540,7 @@
           </p:nvPr>
         </p:nvGraphicFramePr>
         <p:xfrm>
-          <a:off x="457200" y="2596896"/>
+          <a:off x="457200" y="2779776"/>
           <a:ext cx="4046220" cy="914400"/>
         </p:xfrm>
         <a:graphic>
@@ -12346,7 +12346,7 @@
         </p:nvSpPr>
         <p:spPr>
           <a:xfrm>
-            <a:off x="4640580" y="2395728"/>
+            <a:off x="4640580" y="2578608"/>
             <a:ext cx="4046220" cy="164592"/>
           </a:xfrm>
           <a:prstGeom prst="rect">
@@ -12382,7 +12382,7 @@
         </p:nvSpPr>
         <p:spPr>
           <a:xfrm>
-            <a:off x="4640580" y="2596896"/>
+            <a:off x="4640580" y="2779776"/>
             <a:ext cx="4046220" cy="310896"/>
           </a:xfrm>
           <a:prstGeom prst="roundRect">
@@ -12409,7 +12409,7 @@
         </p:nvSpPr>
         <p:spPr>
           <a:xfrm>
-            <a:off x="4713732" y="2624328"/>
+            <a:off x="4713732" y="2807208"/>
             <a:ext cx="3899916" cy="182880"/>
           </a:xfrm>
           <a:prstGeom prst="rect">
@@ -12448,7 +12448,7 @@
         </p:nvSpPr>
         <p:spPr>
           <a:xfrm>
-            <a:off x="4713732" y="2807208"/>
+            <a:off x="4713732" y="2990088"/>
             <a:ext cx="3899916" cy="73152"/>
           </a:xfrm>
           <a:prstGeom prst="rect">
@@ -12487,7 +12487,7 @@
         </p:nvSpPr>
         <p:spPr>
           <a:xfrm>
-            <a:off x="4640580" y="2944368"/>
+            <a:off x="4640580" y="3127248"/>
             <a:ext cx="4046220" cy="310896"/>
           </a:xfrm>
           <a:prstGeom prst="roundRect">
@@ -12514,7 +12514,7 @@
         </p:nvSpPr>
         <p:spPr>
           <a:xfrm>
-            <a:off x="4713732" y="2971800"/>
+            <a:off x="4713732" y="3154680"/>
             <a:ext cx="3899916" cy="182880"/>
           </a:xfrm>
           <a:prstGeom prst="rect">
@@ -12553,7 +12553,7 @@
         </p:nvSpPr>
         <p:spPr>
           <a:xfrm>
-            <a:off x="4713732" y="3154680"/>
+            <a:off x="4713732" y="3337560"/>
             <a:ext cx="3899916" cy="73152"/>
           </a:xfrm>
           <a:prstGeom prst="rect">
@@ -12592,7 +12592,7 @@
         </p:nvSpPr>
         <p:spPr>
           <a:xfrm>
-            <a:off x="4640580" y="3291840"/>
+            <a:off x="4640580" y="3474720"/>
             <a:ext cx="4046220" cy="310896"/>
           </a:xfrm>
           <a:prstGeom prst="roundRect">
@@ -12619,7 +12619,7 @@
         </p:nvSpPr>
         <p:spPr>
           <a:xfrm>
-            <a:off x="4713732" y="3319272"/>
+            <a:off x="4713732" y="3502152"/>
             <a:ext cx="3899916" cy="182880"/>
           </a:xfrm>
           <a:prstGeom prst="rect">
@@ -12658,7 +12658,7 @@
         </p:nvSpPr>
         <p:spPr>
           <a:xfrm>
-            <a:off x="4713732" y="3502152"/>
+            <a:off x="4713732" y="3685032"/>
             <a:ext cx="3899916" cy="73152"/>
           </a:xfrm>
           <a:prstGeom prst="rect">
@@ -12729,7 +12729,7 @@
         </p:nvSpPr>
         <p:spPr>
           <a:xfrm>
-            <a:off x="457200" y="4892040"/>
+            <a:off x="457200" y="5010912"/>
             <a:ext cx="8229600" cy="27432"/>
           </a:xfrm>
           <a:prstGeom prst="rect">
@@ -12749,7 +12749,7 @@
         </p:nvSpPr>
         <p:spPr>
           <a:xfrm>
-            <a:off x="457200" y="4983480"/>
+            <a:off x="457200" y="5084064"/>
             <a:ext cx="8229600" cy="182880"/>
           </a:xfrm>
           <a:prstGeom prst="rect">
@@ -17566,7 +17566,7 @@
         </p:nvSpPr>
         <p:spPr>
           <a:xfrm>
-            <a:off x="457200" y="2880360"/>
+            <a:off x="457200" y="2971800"/>
             <a:ext cx="8229600" cy="164592"/>
           </a:xfrm>
           <a:prstGeom prst="rect">
@@ -17609,7 +17609,7 @@
           </p:nvPr>
         </p:nvGraphicFramePr>
         <p:xfrm>
-          <a:off x="457200" y="3063240"/>
+          <a:off x="457200" y="3182112"/>
           <a:ext cx="8229600" cy="914400"/>
         </p:xfrm>
         <a:graphic>
@@ -17896,7 +17896,7 @@
                   </a:tcPr>
                 </a:tc>
               </a:tr>
-              <a:tr h="201168">
+              <a:tr h="219456">
                 <a:tc>
                   <a:txBody>
                     <a:bodyPr/>
@@ -18158,7 +18158,7 @@
                   </a:tcPr>
                 </a:tc>
               </a:tr>
-              <a:tr h="201168">
+              <a:tr h="219456">
                 <a:tc>
                   <a:txBody>
                     <a:bodyPr/>
@@ -18420,7 +18420,7 @@
                   </a:tcPr>
                 </a:tc>
               </a:tr>
-              <a:tr h="201168">
+              <a:tr h="219456">
                 <a:tc>
                   <a:txBody>
                     <a:bodyPr/>
@@ -18694,7 +18694,7 @@
         </p:nvSpPr>
         <p:spPr>
           <a:xfrm>
-            <a:off x="457200" y="4069080"/>
+            <a:off x="457200" y="4297680"/>
             <a:ext cx="8229600" cy="256032"/>
           </a:xfrm>
           <a:prstGeom prst="roundRect">
@@ -18721,7 +18721,7 @@
         </p:nvSpPr>
         <p:spPr>
           <a:xfrm>
-            <a:off x="594360" y="4078224"/>
+            <a:off x="594360" y="4306824"/>
             <a:ext cx="7955280" cy="237744"/>
           </a:xfrm>
           <a:prstGeom prst="rect">

</xml_diff>

<commit_message>
docs: Day1下午重组 — 14:30L3推演, 15:30L3 Live, 16:40W1
</commit_message>
<xml_diff>
--- a/docs/AI-Native-训战营-介绍与日程.pptx
+++ b/docs/AI-Native-训战营-介绍与日程.pptx
@@ -6064,7 +6064,7 @@
                           <a:ea typeface="Arial" pitchFamily="34" charset="-122"/>
                           <a:cs typeface="Arial" pitchFamily="34" charset="-120"/>
                         </a:rPr>
-                        <a:t>L1+L2 演示 45min</a:t>
+                        <a:t>L3 全流程推演 45min</a:t>
                       </a:r>
                       <a:endParaRPr lang="en-US" sz="650" dirty="0">
                         <a:latin typeface="Arial" charset="0"/>
@@ -6132,7 +6132,7 @@
                           <a:ea typeface="Arial" pitchFamily="34" charset="-122"/>
                           <a:cs typeface="Arial" pitchFamily="34" charset="-120"/>
                         </a:rPr>
-                        <a:t>L1: 传统vs AI Native  L2: /tokens操作</a:t>
+                        <a:t>完整推演[加单位换算] Spec-&gt;Code 不剪辑</a:t>
                       </a:r>
                       <a:endParaRPr lang="en-US" sz="650" dirty="0">
                         <a:latin typeface="Arial" charset="0"/>
@@ -6450,7 +6450,7 @@
                           <a:ea typeface="Arial" pitchFamily="34" charset="-122"/>
                           <a:cs typeface="Arial" pitchFamily="34" charset="-120"/>
                         </a:rPr>
-                        <a:t>Workshop 1: 高级实战 60min</a:t>
+                        <a:t>L3 Live Coding 60min</a:t>
                       </a:r>
                       <a:endParaRPr lang="en-US" sz="650" dirty="0">
                         <a:latin typeface="Arial" charset="0"/>
@@ -6497,7 +6497,7 @@
                       <a:tailEnd type="none" w="med" len="med"/>
                     </a:lnB>
                     <a:solidFill>
-                      <a:srgbClr val="FFF7ED"/>
+                      <a:srgbClr val="EFF6FF"/>
                     </a:solidFill>
                   </a:tcPr>
                 </a:tc>
@@ -6518,7 +6518,7 @@
                           <a:ea typeface="Arial" pitchFamily="34" charset="-122"/>
                           <a:cs typeface="Arial" pitchFamily="34" charset="-120"/>
                         </a:rPr>
-                        <a:t>hooks/上下文/Token · 工作流搭建 · 增量实战</a:t>
+                        <a:t>学员跟做: 在自己的终端完成同一需求 · 对比点评</a:t>
                       </a:r>
                       <a:endParaRPr lang="en-US" sz="650" dirty="0">
                         <a:latin typeface="Arial" charset="0"/>
@@ -6836,7 +6836,7 @@
                           <a:ea typeface="Arial" pitchFamily="34" charset="-122"/>
                           <a:cs typeface="Arial" pitchFamily="34" charset="-120"/>
                         </a:rPr>
-                        <a:t>L3 Live Coding 60min</a:t>
+                        <a:t>Workshop 1: 高级实战 60min</a:t>
                       </a:r>
                       <a:endParaRPr lang="en-US" sz="650" dirty="0">
                         <a:latin typeface="Arial" charset="0"/>
@@ -6883,7 +6883,7 @@
                       <a:tailEnd type="none" w="med" len="med"/>
                     </a:lnB>
                     <a:solidFill>
-                      <a:srgbClr val="EFF6FF"/>
+                      <a:srgbClr val="FFF7ED"/>
                     </a:solidFill>
                   </a:tcPr>
                 </a:tc>
@@ -6904,7 +6904,7 @@
                           <a:ea typeface="Arial" pitchFamily="34" charset="-122"/>
                           <a:cs typeface="Arial" pitchFamily="34" charset="-120"/>
                         </a:rPr>
-                        <a:t>完整演示[加单位换算] Spec-&gt;Code 不剪辑</a:t>
+                        <a:t>hooks/上下文/Token · 工作流搭建 · 增量实战</a:t>
                       </a:r>
                       <a:endParaRPr lang="en-US" sz="650" dirty="0">
                         <a:latin typeface="Arial" charset="0"/>

</xml_diff>

<commit_message>
docs: W1→14:30, L5↔W2互换, Slide1"增量开发和重构"
</commit_message>
<xml_diff>
--- a/docs/AI-Native-训战营-介绍与日程.pptx
+++ b/docs/AI-Native-训战营-介绍与日程.pptx
@@ -1606,7 +1606,7 @@
                   <a:srgbClr val="64748B"/>
                 </a:solidFill>
               </a:rPr>
-              <a:t>上午 9:30-12:00 讲座  |  下午 14:30-18:00 演示+演练  |  L4: 增量开发与重构</a:t>
+              <a:t>上午 9:30-12:00 讲座  |  下午 14:30-18:00 演练+演示  |  L4: 增量开发与重构</a:t>
             </a:r>
             <a:endParaRPr lang="en-US" sz="1100" dirty="0"/>
           </a:p>
@@ -1669,7 +1669,7 @@
                   <a:srgbClr val="2563EB"/>
                 </a:solidFill>
               </a:rPr>
-              <a:t>训前(1.5h): Prompt基础 + LLM概念 + Claude Code安装  -&gt;  课堂不讲基础</a:t>
+              <a:t>训前(1.5h): Prompt基础 + LLM概念 + Claude Code安装</a:t>
             </a:r>
             <a:endParaRPr lang="en-US" sz="1000" dirty="0"/>
           </a:p>
@@ -1808,7 +1808,7 @@
                   <a:srgbClr val="64748B"/>
                 </a:solidFill>
               </a:rPr>
-              <a:t>下午 演示+W1+L3</a:t>
+              <a:t>下午 W1实战+L3推演</a:t>
             </a:r>
             <a:endParaRPr lang="en-US" sz="700" dirty="0"/>
           </a:p>
@@ -1913,7 +1913,7 @@
                   <a:srgbClr val="64748B"/>
                 </a:solidFill>
               </a:rPr>
-              <a:t>增量开发+最佳实践</a:t>
+              <a:t>增量开发和重构</a:t>
             </a:r>
             <a:endParaRPr lang="en-US" sz="700" dirty="0"/>
           </a:p>
@@ -1930,7 +1930,7 @@
                   <a:srgbClr val="64748B"/>
                 </a:solidFill>
               </a:rPr>
-              <a:t>上午 L4增量+L5实践</a:t>
+              <a:t>上午 L4讲座+W2实操</a:t>
             </a:r>
             <a:endParaRPr lang="en-US" sz="700" dirty="0"/>
           </a:p>
@@ -1947,7 +1947,7 @@
                   <a:srgbClr val="64748B"/>
                 </a:solidFill>
               </a:rPr>
-              <a:t>下午 W2重构+W3+L6</a:t>
+              <a:t>下午 L5实践+W3项目</a:t>
             </a:r>
             <a:endParaRPr lang="en-US" sz="700" dirty="0"/>
           </a:p>
@@ -2052,7 +2052,7 @@
                   <a:srgbClr val="64748B"/>
                 </a:solidFill>
               </a:rPr>
-              <a:t>上午讲座(&lt;=12:00)</a:t>
+              <a:t>上午讲座/演练(&lt;=12:15)</a:t>
             </a:r>
             <a:endParaRPr lang="en-US" sz="700" dirty="0"/>
           </a:p>
@@ -2069,7 +2069,7 @@
                   <a:srgbClr val="64748B"/>
                 </a:solidFill>
               </a:rPr>
-              <a:t>下午先演示后演练</a:t>
+              <a:t>下午讲座/演练</a:t>
             </a:r>
             <a:endParaRPr lang="en-US" sz="700" dirty="0"/>
           </a:p>
@@ -2656,7 +2656,7 @@
                   <a:srgbClr val="64748B"/>
                 </a:solidFill>
               </a:rPr>
-              <a:t>60m</a:t>
+              <a:t>105m</a:t>
             </a:r>
             <a:endParaRPr lang="en-US" sz="650" dirty="0"/>
           </a:p>
@@ -3255,7 +3255,21 @@
                   <a:srgbClr val="2563EB"/>
                 </a:solidFill>
               </a:rPr>
-              <a:t>下午 演示+演练 (14:30-18:00)\nL3推演+跟做 105m | W1 60m</a:t>
+              <a:t>下午 演练+演示 (14:30-18:00)</a:t>
+            </a:r>
+            <a:endParaRPr lang="en-US" sz="700" dirty="0"/>
+          </a:p>
+          <a:p>
+            <a:pPr algn="ctr" indent="0" marL="0">
+              <a:buNone/>
+            </a:pPr>
+            <a:r>
+              <a:rPr lang="en-US" sz="700" b="1" dirty="0">
+                <a:solidFill>
+                  <a:srgbClr val="2563EB"/>
+                </a:solidFill>
+              </a:rPr>
+              <a:t>W1实战 60m | L3推演+跟做 105m</a:t>
             </a:r>
             <a:endParaRPr lang="en-US" sz="700" dirty="0"/>
           </a:p>
@@ -3291,7 +3305,7 @@
                   <a:srgbClr val="1A1A2E"/>
                 </a:solidFill>
               </a:rPr>
-              <a:t>Day 2: 增量开发+最佳实践</a:t>
+              <a:t>Day 2: 增量开发和重构</a:t>
             </a:r>
             <a:endParaRPr lang="en-US" sz="1000" dirty="0"/>
           </a:p>
@@ -3354,7 +3368,7 @@
                   <a:srgbClr val="2563EB"/>
                 </a:solidFill>
               </a:rPr>
-              <a:t>上午 讲座 (9:30-11:50)</a:t>
+              <a:t>上午 讲座+演练 (9:30-12:15)</a:t>
             </a:r>
             <a:endParaRPr lang="en-US" sz="700" dirty="0"/>
           </a:p>
@@ -3368,7 +3382,7 @@
                   <a:srgbClr val="2563EB"/>
                 </a:solidFill>
               </a:rPr>
-              <a:t>L4 增量重构 75min | L5 实践 50min</a:t>
+              <a:t>L4 增量重构 75min | W2 实操 75min</a:t>
             </a:r>
             <a:endParaRPr lang="en-US" sz="700" dirty="0"/>
           </a:p>
@@ -3431,7 +3445,21 @@
                   <a:srgbClr val="2563EB"/>
                 </a:solidFill>
               </a:rPr>
-              <a:t>下午 演练 (14:30-18:00)\nW2重构 75m | W3项目 60m | 评审+L6</a:t>
+              <a:t>下午 讲座+演练 (14:30-17:50)</a:t>
+            </a:r>
+            <a:endParaRPr lang="en-US" sz="700" dirty="0"/>
+          </a:p>
+          <a:p>
+            <a:pPr algn="ctr" indent="0" marL="0">
+              <a:buNone/>
+            </a:pPr>
+            <a:r>
+              <a:rPr lang="en-US" sz="700" b="1" dirty="0">
+                <a:solidFill>
+                  <a:srgbClr val="2563EB"/>
+                </a:solidFill>
+              </a:rPr>
+              <a:t>L5 实践 50m | W3 项目 60m | 总结+L6</a:t>
             </a:r>
             <a:endParaRPr lang="en-US" sz="700" dirty="0"/>
           </a:p>
@@ -3460,9 +3488,9 @@
             <a:tbl>
               <a:tblPr/>
               <a:tblGrid>
-                <a:gridCol w="1463040"/>
-                <a:gridCol w="3383280"/>
-                <a:gridCol w="3383280"/>
+                <a:gridCol w="1645920"/>
+                <a:gridCol w="3291840"/>
+                <a:gridCol w="3291840"/>
               </a:tblGrid>
               <a:tr h="164592">
                 <a:tc>
@@ -3677,7 +3705,7 @@
                           <a:ea typeface="Arial" pitchFamily="34" charset="-122"/>
                           <a:cs typeface="Arial" pitchFamily="34" charset="-120"/>
                         </a:rPr>
-                        <a:t>讲座</a:t>
+                        <a:t>讲座(上午)</a:t>
                       </a:r>
                       <a:endParaRPr lang="en-US" sz="650" dirty="0">
                         <a:latin typeface="Arial" charset="0"/>
@@ -3807,7 +3835,7 @@
                           <a:ea typeface="Arial" pitchFamily="34" charset="-122"/>
                           <a:cs typeface="Arial" pitchFamily="34" charset="-120"/>
                         </a:rPr>
-                        <a:t>L4+L5 (125min)</a:t>
+                        <a:t>L4+W2实操 (150min)</a:t>
                       </a:r>
                       <a:endParaRPr lang="en-US" sz="650" dirty="0">
                         <a:latin typeface="Arial" charset="0"/>
@@ -3874,7 +3902,7 @@
                           <a:ea typeface="Arial" pitchFamily="34" charset="-122"/>
                           <a:cs typeface="Arial" pitchFamily="34" charset="-120"/>
                         </a:rPr>
-                        <a:t>演示</a:t>
+                        <a:t>演练/演示(下午)</a:t>
                       </a:r>
                       <a:endParaRPr lang="en-US" sz="650" dirty="0">
                         <a:latin typeface="Arial" charset="0"/>
@@ -3939,7 +3967,7 @@
                           <a:ea typeface="Arial" pitchFamily="34" charset="-122"/>
                           <a:cs typeface="Arial" pitchFamily="34" charset="-120"/>
                         </a:rPr>
-                        <a:t>L3 推演+跟做 (105min)</a:t>
+                        <a:t>W1实战+L3推演 (165min)</a:t>
                       </a:r>
                       <a:endParaRPr lang="en-US" sz="650" dirty="0">
                         <a:latin typeface="Arial" charset="0"/>
@@ -4004,204 +4032,7 @@
                           <a:ea typeface="Arial" pitchFamily="34" charset="-122"/>
                           <a:cs typeface="Arial" pitchFamily="34" charset="-120"/>
                         </a:rPr>
-                        <a:t>--</a:t>
-                      </a:r>
-                      <a:endParaRPr lang="en-US" sz="650" dirty="0">
-                        <a:latin typeface="Arial" charset="0"/>
-                        <a:ea typeface="Arial" charset="0"/>
-                        <a:cs typeface="Arial" charset="0"/>
-                      </a:endParaRPr>
-                    </a:p>
-                  </a:txBody>
-                  <a:tcPr marL="38100" marR="38100" marT="25400" marB="25400">
-                    <a:lnL w="6350" cap="flat" cmpd="sng" algn="ctr">
-                      <a:solidFill>
-                        <a:srgbClr val="666666"/>
-                      </a:solidFill>
-                      <a:prstDash val="solid"/>
-                      <a:round/>
-                      <a:headEnd type="none" w="med" len="med"/>
-                      <a:tailEnd type="none" w="med" len="med"/>
-                    </a:lnL>
-                    <a:lnR w="6350" cap="flat" cmpd="sng" algn="ctr">
-                      <a:solidFill>
-                        <a:srgbClr val="666666"/>
-                      </a:solidFill>
-                      <a:prstDash val="solid"/>
-                      <a:round/>
-                      <a:headEnd type="none" w="med" len="med"/>
-                      <a:tailEnd type="none" w="med" len="med"/>
-                    </a:lnR>
-                    <a:lnT w="6350" cap="flat" cmpd="sng" algn="ctr">
-                      <a:solidFill>
-                        <a:srgbClr val="666666"/>
-                      </a:solidFill>
-                      <a:prstDash val="solid"/>
-                      <a:round/>
-                      <a:headEnd type="none" w="med" len="med"/>
-                      <a:tailEnd type="none" w="med" len="med"/>
-                    </a:lnT>
-                    <a:lnB w="6350" cap="flat" cmpd="sng" algn="ctr">
-                      <a:solidFill>
-                        <a:srgbClr val="666666"/>
-                      </a:solidFill>
-                      <a:prstDash val="solid"/>
-                      <a:round/>
-                      <a:headEnd type="none" w="med" len="med"/>
-                      <a:tailEnd type="none" w="med" len="med"/>
-                    </a:lnB>
-                  </a:tcPr>
-                </a:tc>
-              </a:tr>
-              <a:tr h="256032">
-                <a:tc>
-                  <a:txBody>
-                    <a:bodyPr/>
-                    <a:lstStyle/>
-                    <a:p>
-                      <a:pPr indent="0" marL="0">
-                        <a:buNone/>
-                      </a:pPr>
-                      <a:r>
-                        <a:rPr lang="en-US" sz="650" b="1" dirty="0">
-                          <a:solidFill>
-                            <a:srgbClr val="334155"/>
-                          </a:solidFill>
-                          <a:latin typeface="Arial" pitchFamily="34" charset="0"/>
-                          <a:ea typeface="Arial" pitchFamily="34" charset="-122"/>
-                          <a:cs typeface="Arial" pitchFamily="34" charset="-120"/>
-                        </a:rPr>
-                        <a:t>演练</a:t>
-                      </a:r>
-                      <a:endParaRPr lang="en-US" sz="650" dirty="0">
-                        <a:latin typeface="Arial" charset="0"/>
-                        <a:ea typeface="Arial" charset="0"/>
-                        <a:cs typeface="Arial" charset="0"/>
-                      </a:endParaRPr>
-                    </a:p>
-                  </a:txBody>
-                  <a:tcPr marL="38100" marR="38100" marT="25400" marB="25400">
-                    <a:lnL w="6350" cap="flat" cmpd="sng" algn="ctr">
-                      <a:solidFill>
-                        <a:srgbClr val="666666"/>
-                      </a:solidFill>
-                      <a:prstDash val="solid"/>
-                      <a:round/>
-                      <a:headEnd type="none" w="med" len="med"/>
-                      <a:tailEnd type="none" w="med" len="med"/>
-                    </a:lnL>
-                    <a:lnR w="6350" cap="flat" cmpd="sng" algn="ctr">
-                      <a:solidFill>
-                        <a:srgbClr val="666666"/>
-                      </a:solidFill>
-                      <a:prstDash val="solid"/>
-                      <a:round/>
-                      <a:headEnd type="none" w="med" len="med"/>
-                      <a:tailEnd type="none" w="med" len="med"/>
-                    </a:lnR>
-                    <a:lnT w="6350" cap="flat" cmpd="sng" algn="ctr">
-                      <a:solidFill>
-                        <a:srgbClr val="666666"/>
-                      </a:solidFill>
-                      <a:prstDash val="solid"/>
-                      <a:round/>
-                      <a:headEnd type="none" w="med" len="med"/>
-                      <a:tailEnd type="none" w="med" len="med"/>
-                    </a:lnT>
-                    <a:lnB w="6350" cap="flat" cmpd="sng" algn="ctr">
-                      <a:solidFill>
-                        <a:srgbClr val="666666"/>
-                      </a:solidFill>
-                      <a:prstDash val="solid"/>
-                      <a:round/>
-                      <a:headEnd type="none" w="med" len="med"/>
-                      <a:tailEnd type="none" w="med" len="med"/>
-                    </a:lnB>
-                  </a:tcPr>
-                </a:tc>
-                <a:tc>
-                  <a:txBody>
-                    <a:bodyPr/>
-                    <a:lstStyle/>
-                    <a:p>
-                      <a:pPr indent="0" marL="0">
-                        <a:buNone/>
-                      </a:pPr>
-                      <a:r>
-                        <a:rPr lang="en-US" sz="650" dirty="0">
-                          <a:solidFill>
-                            <a:srgbClr val="334155"/>
-                          </a:solidFill>
-                          <a:latin typeface="Arial" pitchFamily="34" charset="0"/>
-                          <a:ea typeface="Arial" pitchFamily="34" charset="-122"/>
-                          <a:cs typeface="Arial" pitchFamily="34" charset="-120"/>
-                        </a:rPr>
-                        <a:t>W1 练手 (60min)</a:t>
-                      </a:r>
-                      <a:endParaRPr lang="en-US" sz="650" dirty="0">
-                        <a:latin typeface="Arial" charset="0"/>
-                        <a:ea typeface="Arial" charset="0"/>
-                        <a:cs typeface="Arial" charset="0"/>
-                      </a:endParaRPr>
-                    </a:p>
-                  </a:txBody>
-                  <a:tcPr marL="38100" marR="38100" marT="25400" marB="25400">
-                    <a:lnL w="6350" cap="flat" cmpd="sng" algn="ctr">
-                      <a:solidFill>
-                        <a:srgbClr val="666666"/>
-                      </a:solidFill>
-                      <a:prstDash val="solid"/>
-                      <a:round/>
-                      <a:headEnd type="none" w="med" len="med"/>
-                      <a:tailEnd type="none" w="med" len="med"/>
-                    </a:lnL>
-                    <a:lnR w="6350" cap="flat" cmpd="sng" algn="ctr">
-                      <a:solidFill>
-                        <a:srgbClr val="666666"/>
-                      </a:solidFill>
-                      <a:prstDash val="solid"/>
-                      <a:round/>
-                      <a:headEnd type="none" w="med" len="med"/>
-                      <a:tailEnd type="none" w="med" len="med"/>
-                    </a:lnR>
-                    <a:lnT w="6350" cap="flat" cmpd="sng" algn="ctr">
-                      <a:solidFill>
-                        <a:srgbClr val="666666"/>
-                      </a:solidFill>
-                      <a:prstDash val="solid"/>
-                      <a:round/>
-                      <a:headEnd type="none" w="med" len="med"/>
-                      <a:tailEnd type="none" w="med" len="med"/>
-                    </a:lnT>
-                    <a:lnB w="6350" cap="flat" cmpd="sng" algn="ctr">
-                      <a:solidFill>
-                        <a:srgbClr val="666666"/>
-                      </a:solidFill>
-                      <a:prstDash val="solid"/>
-                      <a:round/>
-                      <a:headEnd type="none" w="med" len="med"/>
-                      <a:tailEnd type="none" w="med" len="med"/>
-                    </a:lnB>
-                  </a:tcPr>
-                </a:tc>
-                <a:tc>
-                  <a:txBody>
-                    <a:bodyPr/>
-                    <a:lstStyle/>
-                    <a:p>
-                      <a:pPr indent="0" marL="0">
-                        <a:buNone/>
-                      </a:pPr>
-                      <a:r>
-                        <a:rPr lang="en-US" sz="650" dirty="0">
-                          <a:solidFill>
-                            <a:srgbClr val="334155"/>
-                          </a:solidFill>
-                          <a:latin typeface="Arial" pitchFamily="34" charset="0"/>
-                          <a:ea typeface="Arial" pitchFamily="34" charset="-122"/>
-                          <a:cs typeface="Arial" pitchFamily="34" charset="-120"/>
-                        </a:rPr>
-                        <a:t>W2 重构 + W3 项目 (135min)</a:t>
+                        <a:t>L5实践+W3项目 (110min)</a:t>
                       </a:r>
                       <a:endParaRPr lang="en-US" sz="650" dirty="0">
                         <a:latin typeface="Arial" charset="0"/>
@@ -4333,7 +4164,7 @@
                           <a:ea typeface="Arial" pitchFamily="34" charset="-122"/>
                           <a:cs typeface="Arial" pitchFamily="34" charset="-120"/>
                         </a:rPr>
-                        <a:t>回顾 (20min)</a:t>
+                        <a:t>回顾 (30min)</a:t>
                       </a:r>
                       <a:endParaRPr lang="en-US" sz="650" dirty="0">
                         <a:latin typeface="Arial" charset="0"/>
@@ -4398,7 +4229,7 @@
                           <a:ea typeface="Arial" pitchFamily="34" charset="-122"/>
                           <a:cs typeface="Arial" pitchFamily="34" charset="-120"/>
                         </a:rPr>
-                        <a:t>评审 + L6总结 (50min)</a:t>
+                        <a:t>总结 + L6 (50min)</a:t>
                       </a:r>
                       <a:endParaRPr lang="en-US" sz="650" dirty="0">
                         <a:latin typeface="Arial" charset="0"/>
@@ -4459,7 +4290,7 @@
         </p:nvSpPr>
         <p:spPr>
           <a:xfrm>
-            <a:off x="457200" y="4745736"/>
+            <a:off x="457200" y="4562856"/>
             <a:ext cx="8229600" cy="164592"/>
           </a:xfrm>
           <a:prstGeom prst="rect">
@@ -5051,7 +4882,7 @@
                           <a:ea typeface="Arial" pitchFamily="34" charset="-122"/>
                           <a:cs typeface="Arial" pitchFamily="34" charset="-120"/>
                         </a:rPr>
-                        <a:t>痛点便签墙 场景代入</a:t>
+                        <a:t>痛点便签墙</a:t>
                       </a:r>
                       <a:endParaRPr lang="en-US" sz="650" dirty="0">
                         <a:latin typeface="Arial" charset="0"/>
@@ -5248,7 +5079,7 @@
                           <a:ea typeface="Arial" pitchFamily="34" charset="-122"/>
                           <a:cs typeface="Arial" pitchFamily="34" charset="-120"/>
                         </a:rPr>
-                        <a:t>三层模型 SDD融合 12模块数据 CRISPE速讲</a:t>
+                        <a:t>三层模型 SDD融合 12模块数据 CRISPE</a:t>
                       </a:r>
                       <a:endParaRPr lang="en-US" sz="650" dirty="0">
                         <a:latin typeface="Arial" charset="0"/>
@@ -5714,7 +5545,7 @@
                   <a:srgbClr val="1A1A2E"/>
                 </a:solidFill>
               </a:rPr>
-              <a:t>下午 演示+演练 (14:30-18:00)</a:t>
+              <a:t>下午 演练+演示 (14:30-18:00)</a:t>
             </a:r>
             <a:endParaRPr lang="en-US" sz="900" dirty="0"/>
           </a:p>
@@ -5953,7 +5784,7 @@
                   </a:tcPr>
                 </a:tc>
               </a:tr>
-              <a:tr h="384048">
+              <a:tr h="347472">
                 <a:tc>
                   <a:txBody>
                     <a:bodyPr/>
@@ -5972,392 +5803,6 @@
                           <a:cs typeface="Arial" pitchFamily="34" charset="-120"/>
                         </a:rPr>
                         <a:t>14:30</a:t>
-                      </a:r>
-                      <a:endParaRPr lang="en-US" sz="650" dirty="0">
-                        <a:latin typeface="Arial" charset="0"/>
-                        <a:ea typeface="Arial" charset="0"/>
-                        <a:cs typeface="Arial" charset="0"/>
-                      </a:endParaRPr>
-                    </a:p>
-                  </a:txBody>
-                  <a:tcPr marL="38100" marR="38100" marT="25400" marB="25400">
-                    <a:lnL w="6350" cap="flat" cmpd="sng" algn="ctr">
-                      <a:solidFill>
-                        <a:srgbClr val="666666"/>
-                      </a:solidFill>
-                      <a:prstDash val="solid"/>
-                      <a:round/>
-                      <a:headEnd type="none" w="med" len="med"/>
-                      <a:tailEnd type="none" w="med" len="med"/>
-                    </a:lnL>
-                    <a:lnR w="6350" cap="flat" cmpd="sng" algn="ctr">
-                      <a:solidFill>
-                        <a:srgbClr val="666666"/>
-                      </a:solidFill>
-                      <a:prstDash val="solid"/>
-                      <a:round/>
-                      <a:headEnd type="none" w="med" len="med"/>
-                      <a:tailEnd type="none" w="med" len="med"/>
-                    </a:lnR>
-                    <a:lnT w="6350" cap="flat" cmpd="sng" algn="ctr">
-                      <a:solidFill>
-                        <a:srgbClr val="666666"/>
-                      </a:solidFill>
-                      <a:prstDash val="solid"/>
-                      <a:round/>
-                      <a:headEnd type="none" w="med" len="med"/>
-                      <a:tailEnd type="none" w="med" len="med"/>
-                    </a:lnT>
-                    <a:lnB w="6350" cap="flat" cmpd="sng" algn="ctr">
-                      <a:solidFill>
-                        <a:srgbClr val="666666"/>
-                      </a:solidFill>
-                      <a:prstDash val="solid"/>
-                      <a:round/>
-                      <a:headEnd type="none" w="med" len="med"/>
-                      <a:tailEnd type="none" w="med" len="med"/>
-                    </a:lnB>
-                  </a:tcPr>
-                </a:tc>
-                <a:tc>
-                  <a:txBody>
-                    <a:bodyPr/>
-                    <a:lstStyle/>
-                    <a:p>
-                      <a:pPr indent="0" marL="0">
-                        <a:buNone/>
-                      </a:pPr>
-                      <a:r>
-                        <a:rPr lang="en-US" sz="650" dirty="0">
-                          <a:solidFill>
-                            <a:srgbClr val="334155"/>
-                          </a:solidFill>
-                          <a:latin typeface="Arial" pitchFamily="34" charset="0"/>
-                          <a:ea typeface="Arial" pitchFamily="34" charset="-122"/>
-                          <a:cs typeface="Arial" pitchFamily="34" charset="-120"/>
-                        </a:rPr>
-                        <a:t>L3: 全流程推演 105min</a:t>
-                      </a:r>
-                      <a:endParaRPr lang="en-US" sz="650" dirty="0">
-                        <a:latin typeface="Arial" charset="0"/>
-                        <a:ea typeface="Arial" charset="0"/>
-                        <a:cs typeface="Arial" charset="0"/>
-                      </a:endParaRPr>
-                    </a:p>
-                  </a:txBody>
-                  <a:tcPr marL="38100" marR="38100" marT="25400" marB="25400">
-                    <a:lnL w="6350" cap="flat" cmpd="sng" algn="ctr">
-                      <a:solidFill>
-                        <a:srgbClr val="666666"/>
-                      </a:solidFill>
-                      <a:prstDash val="solid"/>
-                      <a:round/>
-                      <a:headEnd type="none" w="med" len="med"/>
-                      <a:tailEnd type="none" w="med" len="med"/>
-                    </a:lnL>
-                    <a:lnR w="6350" cap="flat" cmpd="sng" algn="ctr">
-                      <a:solidFill>
-                        <a:srgbClr val="666666"/>
-                      </a:solidFill>
-                      <a:prstDash val="solid"/>
-                      <a:round/>
-                      <a:headEnd type="none" w="med" len="med"/>
-                      <a:tailEnd type="none" w="med" len="med"/>
-                    </a:lnR>
-                    <a:lnT w="6350" cap="flat" cmpd="sng" algn="ctr">
-                      <a:solidFill>
-                        <a:srgbClr val="666666"/>
-                      </a:solidFill>
-                      <a:prstDash val="solid"/>
-                      <a:round/>
-                      <a:headEnd type="none" w="med" len="med"/>
-                      <a:tailEnd type="none" w="med" len="med"/>
-                    </a:lnT>
-                    <a:lnB w="6350" cap="flat" cmpd="sng" algn="ctr">
-                      <a:solidFill>
-                        <a:srgbClr val="666666"/>
-                      </a:solidFill>
-                      <a:prstDash val="solid"/>
-                      <a:round/>
-                      <a:headEnd type="none" w="med" len="med"/>
-                      <a:tailEnd type="none" w="med" len="med"/>
-                    </a:lnB>
-                    <a:solidFill>
-                      <a:srgbClr val="EFF6FF"/>
-                    </a:solidFill>
-                  </a:tcPr>
-                </a:tc>
-                <a:tc>
-                  <a:txBody>
-                    <a:bodyPr/>
-                    <a:lstStyle/>
-                    <a:p>
-                      <a:pPr indent="0" marL="0">
-                        <a:buNone/>
-                      </a:pPr>
-                      <a:r>
-                        <a:rPr lang="en-US" sz="650" dirty="0">
-                          <a:solidFill>
-                            <a:srgbClr val="334155"/>
-                          </a:solidFill>
-                          <a:latin typeface="Arial" pitchFamily="34" charset="0"/>
-                          <a:ea typeface="Arial" pitchFamily="34" charset="-122"/>
-                          <a:cs typeface="Arial" pitchFamily="34" charset="-120"/>
-                        </a:rPr>
-                        <a:t>推演示范 45min -&gt; 休息 -&gt; 学员跟做+点评 60min</a:t>
-                      </a:r>
-                      <a:endParaRPr lang="en-US" sz="650" dirty="0">
-                        <a:latin typeface="Arial" charset="0"/>
-                        <a:ea typeface="Arial" charset="0"/>
-                        <a:cs typeface="Arial" charset="0"/>
-                      </a:endParaRPr>
-                    </a:p>
-                  </a:txBody>
-                  <a:tcPr marL="38100" marR="38100" marT="25400" marB="25400">
-                    <a:lnL w="6350" cap="flat" cmpd="sng" algn="ctr">
-                      <a:solidFill>
-                        <a:srgbClr val="666666"/>
-                      </a:solidFill>
-                      <a:prstDash val="solid"/>
-                      <a:round/>
-                      <a:headEnd type="none" w="med" len="med"/>
-                      <a:tailEnd type="none" w="med" len="med"/>
-                    </a:lnL>
-                    <a:lnR w="6350" cap="flat" cmpd="sng" algn="ctr">
-                      <a:solidFill>
-                        <a:srgbClr val="666666"/>
-                      </a:solidFill>
-                      <a:prstDash val="solid"/>
-                      <a:round/>
-                      <a:headEnd type="none" w="med" len="med"/>
-                      <a:tailEnd type="none" w="med" len="med"/>
-                    </a:lnR>
-                    <a:lnT w="6350" cap="flat" cmpd="sng" algn="ctr">
-                      <a:solidFill>
-                        <a:srgbClr val="666666"/>
-                      </a:solidFill>
-                      <a:prstDash val="solid"/>
-                      <a:round/>
-                      <a:headEnd type="none" w="med" len="med"/>
-                      <a:tailEnd type="none" w="med" len="med"/>
-                    </a:lnT>
-                    <a:lnB w="6350" cap="flat" cmpd="sng" algn="ctr">
-                      <a:solidFill>
-                        <a:srgbClr val="666666"/>
-                      </a:solidFill>
-                      <a:prstDash val="solid"/>
-                      <a:round/>
-                      <a:headEnd type="none" w="med" len="med"/>
-                      <a:tailEnd type="none" w="med" len="med"/>
-                    </a:lnB>
-                  </a:tcPr>
-                </a:tc>
-              </a:tr>
-              <a:tr h="155448">
-                <a:tc>
-                  <a:txBody>
-                    <a:bodyPr/>
-                    <a:lstStyle/>
-                    <a:p>
-                      <a:pPr indent="0" marL="0">
-                        <a:buNone/>
-                      </a:pPr>
-                      <a:r>
-                        <a:rPr lang="en-US" sz="650" b="1" dirty="0">
-                          <a:solidFill>
-                            <a:srgbClr val="334155"/>
-                          </a:solidFill>
-                          <a:latin typeface="Arial" pitchFamily="34" charset="0"/>
-                          <a:ea typeface="Arial" pitchFamily="34" charset="-122"/>
-                          <a:cs typeface="Arial" pitchFamily="34" charset="-120"/>
-                        </a:rPr>
-                        <a:t>16:30</a:t>
-                      </a:r>
-                      <a:endParaRPr lang="en-US" sz="650" dirty="0">
-                        <a:latin typeface="Arial" charset="0"/>
-                        <a:ea typeface="Arial" charset="0"/>
-                        <a:cs typeface="Arial" charset="0"/>
-                      </a:endParaRPr>
-                    </a:p>
-                  </a:txBody>
-                  <a:tcPr marL="38100" marR="38100" marT="25400" marB="25400">
-                    <a:lnL w="6350" cap="flat" cmpd="sng" algn="ctr">
-                      <a:solidFill>
-                        <a:srgbClr val="666666"/>
-                      </a:solidFill>
-                      <a:prstDash val="solid"/>
-                      <a:round/>
-                      <a:headEnd type="none" w="med" len="med"/>
-                      <a:tailEnd type="none" w="med" len="med"/>
-                    </a:lnL>
-                    <a:lnR w="6350" cap="flat" cmpd="sng" algn="ctr">
-                      <a:solidFill>
-                        <a:srgbClr val="666666"/>
-                      </a:solidFill>
-                      <a:prstDash val="solid"/>
-                      <a:round/>
-                      <a:headEnd type="none" w="med" len="med"/>
-                      <a:tailEnd type="none" w="med" len="med"/>
-                    </a:lnR>
-                    <a:lnT w="6350" cap="flat" cmpd="sng" algn="ctr">
-                      <a:solidFill>
-                        <a:srgbClr val="666666"/>
-                      </a:solidFill>
-                      <a:prstDash val="solid"/>
-                      <a:round/>
-                      <a:headEnd type="none" w="med" len="med"/>
-                      <a:tailEnd type="none" w="med" len="med"/>
-                    </a:lnT>
-                    <a:lnB w="6350" cap="flat" cmpd="sng" algn="ctr">
-                      <a:solidFill>
-                        <a:srgbClr val="666666"/>
-                      </a:solidFill>
-                      <a:prstDash val="solid"/>
-                      <a:round/>
-                      <a:headEnd type="none" w="med" len="med"/>
-                      <a:tailEnd type="none" w="med" len="med"/>
-                    </a:lnB>
-                  </a:tcPr>
-                </a:tc>
-                <a:tc>
-                  <a:txBody>
-                    <a:bodyPr/>
-                    <a:lstStyle/>
-                    <a:p>
-                      <a:pPr indent="0" marL="0">
-                        <a:buNone/>
-                      </a:pPr>
-                      <a:r>
-                        <a:rPr lang="en-US" sz="650" dirty="0">
-                          <a:solidFill>
-                            <a:srgbClr val="334155"/>
-                          </a:solidFill>
-                          <a:latin typeface="Arial" pitchFamily="34" charset="0"/>
-                          <a:ea typeface="Arial" pitchFamily="34" charset="-122"/>
-                          <a:cs typeface="Arial" pitchFamily="34" charset="-120"/>
-                        </a:rPr>
-                        <a:t>休息 10min</a:t>
-                      </a:r>
-                      <a:endParaRPr lang="en-US" sz="650" dirty="0">
-                        <a:latin typeface="Arial" charset="0"/>
-                        <a:ea typeface="Arial" charset="0"/>
-                        <a:cs typeface="Arial" charset="0"/>
-                      </a:endParaRPr>
-                    </a:p>
-                  </a:txBody>
-                  <a:tcPr marL="38100" marR="38100" marT="25400" marB="25400">
-                    <a:lnL w="6350" cap="flat" cmpd="sng" algn="ctr">
-                      <a:solidFill>
-                        <a:srgbClr val="666666"/>
-                      </a:solidFill>
-                      <a:prstDash val="solid"/>
-                      <a:round/>
-                      <a:headEnd type="none" w="med" len="med"/>
-                      <a:tailEnd type="none" w="med" len="med"/>
-                    </a:lnL>
-                    <a:lnR w="6350" cap="flat" cmpd="sng" algn="ctr">
-                      <a:solidFill>
-                        <a:srgbClr val="666666"/>
-                      </a:solidFill>
-                      <a:prstDash val="solid"/>
-                      <a:round/>
-                      <a:headEnd type="none" w="med" len="med"/>
-                      <a:tailEnd type="none" w="med" len="med"/>
-                    </a:lnR>
-                    <a:lnT w="6350" cap="flat" cmpd="sng" algn="ctr">
-                      <a:solidFill>
-                        <a:srgbClr val="666666"/>
-                      </a:solidFill>
-                      <a:prstDash val="solid"/>
-                      <a:round/>
-                      <a:headEnd type="none" w="med" len="med"/>
-                      <a:tailEnd type="none" w="med" len="med"/>
-                    </a:lnT>
-                    <a:lnB w="6350" cap="flat" cmpd="sng" algn="ctr">
-                      <a:solidFill>
-                        <a:srgbClr val="666666"/>
-                      </a:solidFill>
-                      <a:prstDash val="solid"/>
-                      <a:round/>
-                      <a:headEnd type="none" w="med" len="med"/>
-                      <a:tailEnd type="none" w="med" len="med"/>
-                    </a:lnB>
-                  </a:tcPr>
-                </a:tc>
-                <a:tc>
-                  <a:txBody>
-                    <a:bodyPr/>
-                    <a:lstStyle/>
-                    <a:p>
-                      <a:pPr indent="0" marL="0">
-                        <a:buNone/>
-                      </a:pPr>
-                      <a:endParaRPr lang="en-US" sz="650" dirty="0">
-                        <a:latin typeface="Arial" charset="0"/>
-                        <a:ea typeface="Arial" charset="0"/>
-                        <a:cs typeface="Arial" charset="0"/>
-                      </a:endParaRPr>
-                    </a:p>
-                  </a:txBody>
-                  <a:tcPr marL="38100" marR="38100" marT="25400" marB="25400">
-                    <a:lnL w="6350" cap="flat" cmpd="sng" algn="ctr">
-                      <a:solidFill>
-                        <a:srgbClr val="666666"/>
-                      </a:solidFill>
-                      <a:prstDash val="solid"/>
-                      <a:round/>
-                      <a:headEnd type="none" w="med" len="med"/>
-                      <a:tailEnd type="none" w="med" len="med"/>
-                    </a:lnL>
-                    <a:lnR w="6350" cap="flat" cmpd="sng" algn="ctr">
-                      <a:solidFill>
-                        <a:srgbClr val="666666"/>
-                      </a:solidFill>
-                      <a:prstDash val="solid"/>
-                      <a:round/>
-                      <a:headEnd type="none" w="med" len="med"/>
-                      <a:tailEnd type="none" w="med" len="med"/>
-                    </a:lnR>
-                    <a:lnT w="6350" cap="flat" cmpd="sng" algn="ctr">
-                      <a:solidFill>
-                        <a:srgbClr val="666666"/>
-                      </a:solidFill>
-                      <a:prstDash val="solid"/>
-                      <a:round/>
-                      <a:headEnd type="none" w="med" len="med"/>
-                      <a:tailEnd type="none" w="med" len="med"/>
-                    </a:lnT>
-                    <a:lnB w="6350" cap="flat" cmpd="sng" algn="ctr">
-                      <a:solidFill>
-                        <a:srgbClr val="666666"/>
-                      </a:solidFill>
-                      <a:prstDash val="solid"/>
-                      <a:round/>
-                      <a:headEnd type="none" w="med" len="med"/>
-                      <a:tailEnd type="none" w="med" len="med"/>
-                    </a:lnB>
-                  </a:tcPr>
-                </a:tc>
-              </a:tr>
-              <a:tr h="347472">
-                <a:tc>
-                  <a:txBody>
-                    <a:bodyPr/>
-                    <a:lstStyle/>
-                    <a:p>
-                      <a:pPr indent="0" marL="0">
-                        <a:buNone/>
-                      </a:pPr>
-                      <a:r>
-                        <a:rPr lang="en-US" sz="650" b="1" dirty="0">
-                          <a:solidFill>
-                            <a:srgbClr val="334155"/>
-                          </a:solidFill>
-                          <a:latin typeface="Arial" pitchFamily="34" charset="0"/>
-                          <a:ea typeface="Arial" pitchFamily="34" charset="-122"/>
-                          <a:cs typeface="Arial" pitchFamily="34" charset="-120"/>
-                        </a:rPr>
-                        <a:t>16:40</a:t>
                       </a:r>
                       <a:endParaRPr lang="en-US" sz="650" dirty="0">
                         <a:latin typeface="Arial" charset="0"/>
@@ -6539,7 +5984,7 @@
                   </a:tcPr>
                 </a:tc>
               </a:tr>
-              <a:tr h="274320">
+              <a:tr h="155448">
                 <a:tc>
                   <a:txBody>
                     <a:bodyPr/>
@@ -6557,7 +6002,7 @@
                           <a:ea typeface="Arial" pitchFamily="34" charset="-122"/>
                           <a:cs typeface="Arial" pitchFamily="34" charset="-120"/>
                         </a:rPr>
-                        <a:t>17:40</a:t>
+                        <a:t>15:30</a:t>
                       </a:r>
                       <a:endParaRPr lang="en-US" sz="650" dirty="0">
                         <a:latin typeface="Arial" charset="0"/>
@@ -6622,7 +6067,393 @@
                           <a:ea typeface="Arial" pitchFamily="34" charset="-122"/>
                           <a:cs typeface="Arial" pitchFamily="34" charset="-120"/>
                         </a:rPr>
-                        <a:t>Day1回顾+Q&amp;A 20min</a:t>
+                        <a:t>休息 15min</a:t>
+                      </a:r>
+                      <a:endParaRPr lang="en-US" sz="650" dirty="0">
+                        <a:latin typeface="Arial" charset="0"/>
+                        <a:ea typeface="Arial" charset="0"/>
+                        <a:cs typeface="Arial" charset="0"/>
+                      </a:endParaRPr>
+                    </a:p>
+                  </a:txBody>
+                  <a:tcPr marL="38100" marR="38100" marT="25400" marB="25400">
+                    <a:lnL w="6350" cap="flat" cmpd="sng" algn="ctr">
+                      <a:solidFill>
+                        <a:srgbClr val="666666"/>
+                      </a:solidFill>
+                      <a:prstDash val="solid"/>
+                      <a:round/>
+                      <a:headEnd type="none" w="med" len="med"/>
+                      <a:tailEnd type="none" w="med" len="med"/>
+                    </a:lnL>
+                    <a:lnR w="6350" cap="flat" cmpd="sng" algn="ctr">
+                      <a:solidFill>
+                        <a:srgbClr val="666666"/>
+                      </a:solidFill>
+                      <a:prstDash val="solid"/>
+                      <a:round/>
+                      <a:headEnd type="none" w="med" len="med"/>
+                      <a:tailEnd type="none" w="med" len="med"/>
+                    </a:lnR>
+                    <a:lnT w="6350" cap="flat" cmpd="sng" algn="ctr">
+                      <a:solidFill>
+                        <a:srgbClr val="666666"/>
+                      </a:solidFill>
+                      <a:prstDash val="solid"/>
+                      <a:round/>
+                      <a:headEnd type="none" w="med" len="med"/>
+                      <a:tailEnd type="none" w="med" len="med"/>
+                    </a:lnT>
+                    <a:lnB w="6350" cap="flat" cmpd="sng" algn="ctr">
+                      <a:solidFill>
+                        <a:srgbClr val="666666"/>
+                      </a:solidFill>
+                      <a:prstDash val="solid"/>
+                      <a:round/>
+                      <a:headEnd type="none" w="med" len="med"/>
+                      <a:tailEnd type="none" w="med" len="med"/>
+                    </a:lnB>
+                  </a:tcPr>
+                </a:tc>
+                <a:tc>
+                  <a:txBody>
+                    <a:bodyPr/>
+                    <a:lstStyle/>
+                    <a:p>
+                      <a:pPr indent="0" marL="0">
+                        <a:buNone/>
+                      </a:pPr>
+                      <a:endParaRPr lang="en-US" sz="650" dirty="0">
+                        <a:latin typeface="Arial" charset="0"/>
+                        <a:ea typeface="Arial" charset="0"/>
+                        <a:cs typeface="Arial" charset="0"/>
+                      </a:endParaRPr>
+                    </a:p>
+                  </a:txBody>
+                  <a:tcPr marL="38100" marR="38100" marT="25400" marB="25400">
+                    <a:lnL w="6350" cap="flat" cmpd="sng" algn="ctr">
+                      <a:solidFill>
+                        <a:srgbClr val="666666"/>
+                      </a:solidFill>
+                      <a:prstDash val="solid"/>
+                      <a:round/>
+                      <a:headEnd type="none" w="med" len="med"/>
+                      <a:tailEnd type="none" w="med" len="med"/>
+                    </a:lnL>
+                    <a:lnR w="6350" cap="flat" cmpd="sng" algn="ctr">
+                      <a:solidFill>
+                        <a:srgbClr val="666666"/>
+                      </a:solidFill>
+                      <a:prstDash val="solid"/>
+                      <a:round/>
+                      <a:headEnd type="none" w="med" len="med"/>
+                      <a:tailEnd type="none" w="med" len="med"/>
+                    </a:lnR>
+                    <a:lnT w="6350" cap="flat" cmpd="sng" algn="ctr">
+                      <a:solidFill>
+                        <a:srgbClr val="666666"/>
+                      </a:solidFill>
+                      <a:prstDash val="solid"/>
+                      <a:round/>
+                      <a:headEnd type="none" w="med" len="med"/>
+                      <a:tailEnd type="none" w="med" len="med"/>
+                    </a:lnT>
+                    <a:lnB w="6350" cap="flat" cmpd="sng" algn="ctr">
+                      <a:solidFill>
+                        <a:srgbClr val="666666"/>
+                      </a:solidFill>
+                      <a:prstDash val="solid"/>
+                      <a:round/>
+                      <a:headEnd type="none" w="med" len="med"/>
+                      <a:tailEnd type="none" w="med" len="med"/>
+                    </a:lnB>
+                  </a:tcPr>
+                </a:tc>
+              </a:tr>
+              <a:tr h="384048">
+                <a:tc>
+                  <a:txBody>
+                    <a:bodyPr/>
+                    <a:lstStyle/>
+                    <a:p>
+                      <a:pPr indent="0" marL="0">
+                        <a:buNone/>
+                      </a:pPr>
+                      <a:r>
+                        <a:rPr lang="en-US" sz="650" b="1" dirty="0">
+                          <a:solidFill>
+                            <a:srgbClr val="334155"/>
+                          </a:solidFill>
+                          <a:latin typeface="Arial" pitchFamily="34" charset="0"/>
+                          <a:ea typeface="Arial" pitchFamily="34" charset="-122"/>
+                          <a:cs typeface="Arial" pitchFamily="34" charset="-120"/>
+                        </a:rPr>
+                        <a:t>15:45</a:t>
+                      </a:r>
+                      <a:endParaRPr lang="en-US" sz="650" dirty="0">
+                        <a:latin typeface="Arial" charset="0"/>
+                        <a:ea typeface="Arial" charset="0"/>
+                        <a:cs typeface="Arial" charset="0"/>
+                      </a:endParaRPr>
+                    </a:p>
+                  </a:txBody>
+                  <a:tcPr marL="38100" marR="38100" marT="25400" marB="25400">
+                    <a:lnL w="6350" cap="flat" cmpd="sng" algn="ctr">
+                      <a:solidFill>
+                        <a:srgbClr val="666666"/>
+                      </a:solidFill>
+                      <a:prstDash val="solid"/>
+                      <a:round/>
+                      <a:headEnd type="none" w="med" len="med"/>
+                      <a:tailEnd type="none" w="med" len="med"/>
+                    </a:lnL>
+                    <a:lnR w="6350" cap="flat" cmpd="sng" algn="ctr">
+                      <a:solidFill>
+                        <a:srgbClr val="666666"/>
+                      </a:solidFill>
+                      <a:prstDash val="solid"/>
+                      <a:round/>
+                      <a:headEnd type="none" w="med" len="med"/>
+                      <a:tailEnd type="none" w="med" len="med"/>
+                    </a:lnR>
+                    <a:lnT w="6350" cap="flat" cmpd="sng" algn="ctr">
+                      <a:solidFill>
+                        <a:srgbClr val="666666"/>
+                      </a:solidFill>
+                      <a:prstDash val="solid"/>
+                      <a:round/>
+                      <a:headEnd type="none" w="med" len="med"/>
+                      <a:tailEnd type="none" w="med" len="med"/>
+                    </a:lnT>
+                    <a:lnB w="6350" cap="flat" cmpd="sng" algn="ctr">
+                      <a:solidFill>
+                        <a:srgbClr val="666666"/>
+                      </a:solidFill>
+                      <a:prstDash val="solid"/>
+                      <a:round/>
+                      <a:headEnd type="none" w="med" len="med"/>
+                      <a:tailEnd type="none" w="med" len="med"/>
+                    </a:lnB>
+                  </a:tcPr>
+                </a:tc>
+                <a:tc>
+                  <a:txBody>
+                    <a:bodyPr/>
+                    <a:lstStyle/>
+                    <a:p>
+                      <a:pPr indent="0" marL="0">
+                        <a:buNone/>
+                      </a:pPr>
+                      <a:r>
+                        <a:rPr lang="en-US" sz="650" dirty="0">
+                          <a:solidFill>
+                            <a:srgbClr val="334155"/>
+                          </a:solidFill>
+                          <a:latin typeface="Arial" pitchFamily="34" charset="0"/>
+                          <a:ea typeface="Arial" pitchFamily="34" charset="-122"/>
+                          <a:cs typeface="Arial" pitchFamily="34" charset="-120"/>
+                        </a:rPr>
+                        <a:t>L3: 全流程推演 105min</a:t>
+                      </a:r>
+                      <a:endParaRPr lang="en-US" sz="650" dirty="0">
+                        <a:latin typeface="Arial" charset="0"/>
+                        <a:ea typeface="Arial" charset="0"/>
+                        <a:cs typeface="Arial" charset="0"/>
+                      </a:endParaRPr>
+                    </a:p>
+                  </a:txBody>
+                  <a:tcPr marL="38100" marR="38100" marT="25400" marB="25400">
+                    <a:lnL w="6350" cap="flat" cmpd="sng" algn="ctr">
+                      <a:solidFill>
+                        <a:srgbClr val="666666"/>
+                      </a:solidFill>
+                      <a:prstDash val="solid"/>
+                      <a:round/>
+                      <a:headEnd type="none" w="med" len="med"/>
+                      <a:tailEnd type="none" w="med" len="med"/>
+                    </a:lnL>
+                    <a:lnR w="6350" cap="flat" cmpd="sng" algn="ctr">
+                      <a:solidFill>
+                        <a:srgbClr val="666666"/>
+                      </a:solidFill>
+                      <a:prstDash val="solid"/>
+                      <a:round/>
+                      <a:headEnd type="none" w="med" len="med"/>
+                      <a:tailEnd type="none" w="med" len="med"/>
+                    </a:lnR>
+                    <a:lnT w="6350" cap="flat" cmpd="sng" algn="ctr">
+                      <a:solidFill>
+                        <a:srgbClr val="666666"/>
+                      </a:solidFill>
+                      <a:prstDash val="solid"/>
+                      <a:round/>
+                      <a:headEnd type="none" w="med" len="med"/>
+                      <a:tailEnd type="none" w="med" len="med"/>
+                    </a:lnT>
+                    <a:lnB w="6350" cap="flat" cmpd="sng" algn="ctr">
+                      <a:solidFill>
+                        <a:srgbClr val="666666"/>
+                      </a:solidFill>
+                      <a:prstDash val="solid"/>
+                      <a:round/>
+                      <a:headEnd type="none" w="med" len="med"/>
+                      <a:tailEnd type="none" w="med" len="med"/>
+                    </a:lnB>
+                    <a:solidFill>
+                      <a:srgbClr val="EFF6FF"/>
+                    </a:solidFill>
+                  </a:tcPr>
+                </a:tc>
+                <a:tc>
+                  <a:txBody>
+                    <a:bodyPr/>
+                    <a:lstStyle/>
+                    <a:p>
+                      <a:pPr indent="0" marL="0">
+                        <a:buNone/>
+                      </a:pPr>
+                      <a:r>
+                        <a:rPr lang="en-US" sz="650" dirty="0">
+                          <a:solidFill>
+                            <a:srgbClr val="334155"/>
+                          </a:solidFill>
+                          <a:latin typeface="Arial" pitchFamily="34" charset="0"/>
+                          <a:ea typeface="Arial" pitchFamily="34" charset="-122"/>
+                          <a:cs typeface="Arial" pitchFamily="34" charset="-120"/>
+                        </a:rPr>
+                        <a:t>推演示范 45min · 学员跟做+点评 60min</a:t>
+                      </a:r>
+                      <a:endParaRPr lang="en-US" sz="650" dirty="0">
+                        <a:latin typeface="Arial" charset="0"/>
+                        <a:ea typeface="Arial" charset="0"/>
+                        <a:cs typeface="Arial" charset="0"/>
+                      </a:endParaRPr>
+                    </a:p>
+                  </a:txBody>
+                  <a:tcPr marL="38100" marR="38100" marT="25400" marB="25400">
+                    <a:lnL w="6350" cap="flat" cmpd="sng" algn="ctr">
+                      <a:solidFill>
+                        <a:srgbClr val="666666"/>
+                      </a:solidFill>
+                      <a:prstDash val="solid"/>
+                      <a:round/>
+                      <a:headEnd type="none" w="med" len="med"/>
+                      <a:tailEnd type="none" w="med" len="med"/>
+                    </a:lnL>
+                    <a:lnR w="6350" cap="flat" cmpd="sng" algn="ctr">
+                      <a:solidFill>
+                        <a:srgbClr val="666666"/>
+                      </a:solidFill>
+                      <a:prstDash val="solid"/>
+                      <a:round/>
+                      <a:headEnd type="none" w="med" len="med"/>
+                      <a:tailEnd type="none" w="med" len="med"/>
+                    </a:lnR>
+                    <a:lnT w="6350" cap="flat" cmpd="sng" algn="ctr">
+                      <a:solidFill>
+                        <a:srgbClr val="666666"/>
+                      </a:solidFill>
+                      <a:prstDash val="solid"/>
+                      <a:round/>
+                      <a:headEnd type="none" w="med" len="med"/>
+                      <a:tailEnd type="none" w="med" len="med"/>
+                    </a:lnT>
+                    <a:lnB w="6350" cap="flat" cmpd="sng" algn="ctr">
+                      <a:solidFill>
+                        <a:srgbClr val="666666"/>
+                      </a:solidFill>
+                      <a:prstDash val="solid"/>
+                      <a:round/>
+                      <a:headEnd type="none" w="med" len="med"/>
+                      <a:tailEnd type="none" w="med" len="med"/>
+                    </a:lnB>
+                  </a:tcPr>
+                </a:tc>
+              </a:tr>
+              <a:tr h="274320">
+                <a:tc>
+                  <a:txBody>
+                    <a:bodyPr/>
+                    <a:lstStyle/>
+                    <a:p>
+                      <a:pPr indent="0" marL="0">
+                        <a:buNone/>
+                      </a:pPr>
+                      <a:r>
+                        <a:rPr lang="en-US" sz="650" b="1" dirty="0">
+                          <a:solidFill>
+                            <a:srgbClr val="334155"/>
+                          </a:solidFill>
+                          <a:latin typeface="Arial" pitchFamily="34" charset="0"/>
+                          <a:ea typeface="Arial" pitchFamily="34" charset="-122"/>
+                          <a:cs typeface="Arial" pitchFamily="34" charset="-120"/>
+                        </a:rPr>
+                        <a:t>17:30</a:t>
+                      </a:r>
+                      <a:endParaRPr lang="en-US" sz="650" dirty="0">
+                        <a:latin typeface="Arial" charset="0"/>
+                        <a:ea typeface="Arial" charset="0"/>
+                        <a:cs typeface="Arial" charset="0"/>
+                      </a:endParaRPr>
+                    </a:p>
+                  </a:txBody>
+                  <a:tcPr marL="38100" marR="38100" marT="25400" marB="25400">
+                    <a:lnL w="6350" cap="flat" cmpd="sng" algn="ctr">
+                      <a:solidFill>
+                        <a:srgbClr val="666666"/>
+                      </a:solidFill>
+                      <a:prstDash val="solid"/>
+                      <a:round/>
+                      <a:headEnd type="none" w="med" len="med"/>
+                      <a:tailEnd type="none" w="med" len="med"/>
+                    </a:lnL>
+                    <a:lnR w="6350" cap="flat" cmpd="sng" algn="ctr">
+                      <a:solidFill>
+                        <a:srgbClr val="666666"/>
+                      </a:solidFill>
+                      <a:prstDash val="solid"/>
+                      <a:round/>
+                      <a:headEnd type="none" w="med" len="med"/>
+                      <a:tailEnd type="none" w="med" len="med"/>
+                    </a:lnR>
+                    <a:lnT w="6350" cap="flat" cmpd="sng" algn="ctr">
+                      <a:solidFill>
+                        <a:srgbClr val="666666"/>
+                      </a:solidFill>
+                      <a:prstDash val="solid"/>
+                      <a:round/>
+                      <a:headEnd type="none" w="med" len="med"/>
+                      <a:tailEnd type="none" w="med" len="med"/>
+                    </a:lnT>
+                    <a:lnB w="6350" cap="flat" cmpd="sng" algn="ctr">
+                      <a:solidFill>
+                        <a:srgbClr val="666666"/>
+                      </a:solidFill>
+                      <a:prstDash val="solid"/>
+                      <a:round/>
+                      <a:headEnd type="none" w="med" len="med"/>
+                      <a:tailEnd type="none" w="med" len="med"/>
+                    </a:lnB>
+                  </a:tcPr>
+                </a:tc>
+                <a:tc>
+                  <a:txBody>
+                    <a:bodyPr/>
+                    <a:lstStyle/>
+                    <a:p>
+                      <a:pPr indent="0" marL="0">
+                        <a:buNone/>
+                      </a:pPr>
+                      <a:r>
+                        <a:rPr lang="en-US" sz="650" dirty="0">
+                          <a:solidFill>
+                            <a:srgbClr val="334155"/>
+                          </a:solidFill>
+                          <a:latin typeface="Arial" pitchFamily="34" charset="0"/>
+                          <a:ea typeface="Arial" pitchFamily="34" charset="-122"/>
+                          <a:cs typeface="Arial" pitchFamily="34" charset="-120"/>
+                        </a:rPr>
+                        <a:t>Day1回顾+Q&amp;A 30min</a:t>
                       </a:r>
                       <a:endParaRPr lang="en-US" sz="650" dirty="0">
                         <a:latin typeface="Arial" charset="0"/>
@@ -6917,7 +6748,7 @@
                   <a:srgbClr val="1A1A2E"/>
                 </a:solidFill>
               </a:rPr>
-              <a:t>上午 讲座 (9:30-11:50)</a:t>
+              <a:t>上午 讲座+演练 (9:30-12:15)</a:t>
             </a:r>
             <a:endParaRPr lang="en-US" sz="900" dirty="0"/>
           </a:p>
@@ -7539,7 +7370,7 @@
                   </a:tcPr>
                 </a:tc>
               </a:tr>
-              <a:tr h="329184">
+              <a:tr h="347472">
                 <a:tc>
                   <a:txBody>
                     <a:bodyPr/>
@@ -7622,7 +7453,7 @@
                           <a:ea typeface="Arial" pitchFamily="34" charset="-122"/>
                           <a:cs typeface="Arial" pitchFamily="34" charset="-120"/>
                         </a:rPr>
-                        <a:t>L5: 工程最佳实践 50min</a:t>
+                        <a:t>Workshop 2: 增量重构 75min</a:t>
                       </a:r>
                       <a:endParaRPr lang="en-US" sz="650" dirty="0">
                         <a:latin typeface="Arial" charset="0"/>
@@ -7668,6 +7499,9 @@
                       <a:headEnd type="none" w="med" len="med"/>
                       <a:tailEnd type="none" w="med" len="med"/>
                     </a:lnB>
+                    <a:solidFill>
+                      <a:srgbClr val="FFF7ED"/>
+                    </a:solidFill>
                   </a:tcPr>
                 </a:tc>
                 <a:tc>
@@ -7687,7 +7521,7 @@
                           <a:ea typeface="Arial" pitchFamily="34" charset="-122"/>
                           <a:cs typeface="Arial" pitchFamily="34" charset="-120"/>
                         </a:rPr>
-                        <a:t>70/30法则 审查清单 三重门禁 决策矩阵</a:t>
+                        <a:t>A组(全重写)/B组(增量)/C组(手工+AI) 策略对比</a:t>
                       </a:r>
                       <a:endParaRPr lang="en-US" sz="650" dirty="0">
                         <a:latin typeface="Arial" charset="0"/>
@@ -7770,7 +7604,7 @@
                   <a:srgbClr val="1A1A2E"/>
                 </a:solidFill>
               </a:rPr>
-              <a:t>下午 演练 (14:30-18:00)</a:t>
+              <a:t>下午 讲座+演练 (14:30-17:50)</a:t>
             </a:r>
             <a:endParaRPr lang="en-US" sz="900" dirty="0"/>
           </a:p>
@@ -8092,7 +7926,7 @@
                           <a:ea typeface="Arial" pitchFamily="34" charset="-122"/>
                           <a:cs typeface="Arial" pitchFamily="34" charset="-120"/>
                         </a:rPr>
-                        <a:t>Workshop 2: 增量重构 75min</a:t>
+                        <a:t>L5: 工程最佳实践 50min</a:t>
                       </a:r>
                       <a:endParaRPr lang="en-US" sz="650" dirty="0">
                         <a:latin typeface="Arial" charset="0"/>
@@ -8138,9 +7972,6 @@
                       <a:headEnd type="none" w="med" len="med"/>
                       <a:tailEnd type="none" w="med" len="med"/>
                     </a:lnB>
-                    <a:solidFill>
-                      <a:srgbClr val="FFF7ED"/>
-                    </a:solidFill>
                   </a:tcPr>
                 </a:tc>
                 <a:tc>
@@ -8160,7 +7991,7 @@
                           <a:ea typeface="Arial" pitchFamily="34" charset="-122"/>
                           <a:cs typeface="Arial" pitchFamily="34" charset="-120"/>
                         </a:rPr>
-                        <a:t>A组(全重写)/B组(增量)/C组(手工+AI) 策略对比</a:t>
+                        <a:t>效率(70/30) · 质量(审查清单) · 安全(三重门禁) · 决策矩阵</a:t>
                       </a:r>
                       <a:endParaRPr lang="en-US" sz="650" dirty="0">
                         <a:latin typeface="Arial" charset="0"/>
@@ -8227,7 +8058,7 @@
                           <a:ea typeface="Arial" pitchFamily="34" charset="-122"/>
                           <a:cs typeface="Arial" pitchFamily="34" charset="-120"/>
                         </a:rPr>
-                        <a:t>15:45</a:t>
+                        <a:t>15:20</a:t>
                       </a:r>
                       <a:endParaRPr lang="en-US" sz="650" dirty="0">
                         <a:latin typeface="Arial" charset="0"/>
@@ -8413,7 +8244,7 @@
                           <a:ea typeface="Arial" pitchFamily="34" charset="-122"/>
                           <a:cs typeface="Arial" pitchFamily="34" charset="-120"/>
                         </a:rPr>
-                        <a:t>16:00</a:t>
+                        <a:t>15:35</a:t>
                       </a:r>
                       <a:endParaRPr lang="en-US" sz="650" dirty="0">
                         <a:latin typeface="Arial" charset="0"/>
@@ -8613,7 +8444,7 @@
                           <a:ea typeface="Arial" pitchFamily="34" charset="-122"/>
                           <a:cs typeface="Arial" pitchFamily="34" charset="-120"/>
                         </a:rPr>
-                        <a:t>17:00</a:t>
+                        <a:t>16:35</a:t>
                       </a:r>
                       <a:endParaRPr lang="en-US" sz="650" dirty="0">
                         <a:latin typeface="Arial" charset="0"/>
@@ -8746,7 +8577,7 @@
                           <a:ea typeface="Arial" pitchFamily="34" charset="-122"/>
                           <a:cs typeface="Arial" pitchFamily="34" charset="-120"/>
                         </a:rPr>
-                        <a:t>Day1疑问解答 · 两天问题总结 · 成果展示点评</a:t>
+                        <a:t>Day1疑问解答 · 两天问题总结 · 成果点评</a:t>
                       </a:r>
                       <a:endParaRPr lang="en-US" sz="650" dirty="0">
                         <a:latin typeface="Arial" charset="0"/>
@@ -8813,7 +8644,7 @@
                           <a:ea typeface="Arial" pitchFamily="34" charset="-122"/>
                           <a:cs typeface="Arial" pitchFamily="34" charset="-120"/>
                         </a:rPr>
-                        <a:t>17:30</a:t>
+                        <a:t>17:05</a:t>
                       </a:r>
                       <a:endParaRPr lang="en-US" sz="650" dirty="0">
                         <a:latin typeface="Arial" charset="0"/>
@@ -9010,7 +8841,7 @@
                           <a:ea typeface="Arial" pitchFamily="34" charset="-122"/>
                           <a:cs typeface="Arial" pitchFamily="34" charset="-120"/>
                         </a:rPr>
-                        <a:t>17:50</a:t>
+                        <a:t>17:25</a:t>
                       </a:r>
                       <a:endParaRPr lang="en-US" sz="650" dirty="0">
                         <a:latin typeface="Arial" charset="0"/>
@@ -9686,7 +9517,7 @@
                   <a:srgbClr val="64748B"/>
                 </a:solidFill>
               </a:rPr>
-              <a:t>Live Coding完整演示</a:t>
+              <a:t>推演+跟做</a:t>
             </a:r>
             <a:endParaRPr lang="en-US" sz="700" dirty="0"/>
           </a:p>
@@ -12059,7 +11890,7 @@
                   <a:srgbClr val="64748B"/>
                 </a:solidFill>
               </a:rPr>
-              <a:t>hooks 上下文管理 Token优化 工作流</a:t>
+              <a:t>hooks 上下文管理 Token 工作流</a:t>
             </a:r>
             <a:endParaRPr lang="en-US" sz="700" dirty="0"/>
           </a:p>
@@ -12164,7 +11995,7 @@
                   <a:srgbClr val="64748B"/>
                 </a:solidFill>
               </a:rPr>
-              <a:t>A/B/C三组策略 限时增量(在L4后)</a:t>
+              <a:t>A/B/C三组策略 (在L4后)</a:t>
             </a:r>
             <a:endParaRPr lang="en-US" sz="700" dirty="0"/>
           </a:p>
@@ -12485,7 +12316,7 @@
                 <a:gridCol w="1188720"/>
                 <a:gridCol w="411480"/>
               </a:tblGrid>
-              <a:tr h="137160">
+              <a:tr h="164592">
                 <a:tc>
                   <a:txBody>
                     <a:bodyPr/>
@@ -12691,7 +12522,7 @@
                   </a:tcPr>
                 </a:tc>
               </a:tr>
-              <a:tr h="137160">
+              <a:tr h="164592">
                 <a:tc>
                   <a:txBody>
                     <a:bodyPr/>
@@ -12888,7 +12719,7 @@
                   </a:tcPr>
                 </a:tc>
               </a:tr>
-              <a:tr h="137160">
+              <a:tr h="164592">
                 <a:tc>
                   <a:txBody>
                     <a:bodyPr/>
@@ -13088,7 +12919,7 @@
                   </a:tcPr>
                 </a:tc>
               </a:tr>
-              <a:tr h="137160">
+              <a:tr h="164592">
                 <a:tc>
                   <a:txBody>
                     <a:bodyPr/>
@@ -13285,7 +13116,7 @@
                   </a:tcPr>
                 </a:tc>
               </a:tr>
-              <a:tr h="137160">
+              <a:tr h="164592">
                 <a:tc>
                   <a:txBody>
                     <a:bodyPr/>
@@ -13485,7 +13316,7 @@
                   </a:tcPr>
                 </a:tc>
               </a:tr>
-              <a:tr h="137160">
+              <a:tr h="164592">
                 <a:tc>
                   <a:txBody>
                     <a:bodyPr/>
@@ -13682,7 +13513,7 @@
                   </a:tcPr>
                 </a:tc>
               </a:tr>
-              <a:tr h="137160">
+              <a:tr h="164592">
                 <a:tc>
                   <a:txBody>
                     <a:bodyPr/>
@@ -13765,404 +13596,7 @@
                           <a:ea typeface="Arial" pitchFamily="34" charset="-122"/>
                           <a:cs typeface="Arial" pitchFamily="34" charset="-120"/>
                         </a:rPr>
-                        <a:t>演示</a:t>
-                      </a:r>
-                      <a:endParaRPr lang="en-US" sz="650" dirty="0">
-                        <a:latin typeface="Arial" charset="0"/>
-                        <a:ea typeface="Arial" charset="0"/>
-                        <a:cs typeface="Arial" charset="0"/>
-                      </a:endParaRPr>
-                    </a:p>
-                  </a:txBody>
-                  <a:tcPr marL="38100" marR="38100" marT="25400" marB="25400">
-                    <a:lnL w="6350" cap="flat" cmpd="sng" algn="ctr">
-                      <a:solidFill>
-                        <a:srgbClr val="666666"/>
-                      </a:solidFill>
-                      <a:prstDash val="solid"/>
-                      <a:round/>
-                      <a:headEnd type="none" w="med" len="med"/>
-                      <a:tailEnd type="none" w="med" len="med"/>
-                    </a:lnL>
-                    <a:lnR w="6350" cap="flat" cmpd="sng" algn="ctr">
-                      <a:solidFill>
-                        <a:srgbClr val="666666"/>
-                      </a:solidFill>
-                      <a:prstDash val="solid"/>
-                      <a:round/>
-                      <a:headEnd type="none" w="med" len="med"/>
-                      <a:tailEnd type="none" w="med" len="med"/>
-                    </a:lnR>
-                    <a:lnT w="6350" cap="flat" cmpd="sng" algn="ctr">
-                      <a:solidFill>
-                        <a:srgbClr val="666666"/>
-                      </a:solidFill>
-                      <a:prstDash val="solid"/>
-                      <a:round/>
-                      <a:headEnd type="none" w="med" len="med"/>
-                      <a:tailEnd type="none" w="med" len="med"/>
-                    </a:lnT>
-                    <a:lnB w="6350" cap="flat" cmpd="sng" algn="ctr">
-                      <a:solidFill>
-                        <a:srgbClr val="666666"/>
-                      </a:solidFill>
-                      <a:prstDash val="solid"/>
-                      <a:round/>
-                      <a:headEnd type="none" w="med" len="med"/>
-                      <a:tailEnd type="none" w="med" len="med"/>
-                    </a:lnB>
-                    <a:solidFill>
-                      <a:srgbClr val="EFF6FF"/>
-                    </a:solidFill>
-                  </a:tcPr>
-                </a:tc>
-                <a:tc>
-                  <a:txBody>
-                    <a:bodyPr/>
-                    <a:lstStyle/>
-                    <a:p>
-                      <a:pPr indent="0" marL="0">
-                        <a:buNone/>
-                      </a:pPr>
-                      <a:r>
-                        <a:rPr lang="en-US" sz="650" dirty="0">
-                          <a:solidFill>
-                            <a:srgbClr val="334155"/>
-                          </a:solidFill>
-                          <a:latin typeface="Arial" pitchFamily="34" charset="0"/>
-                          <a:ea typeface="Arial" pitchFamily="34" charset="-122"/>
-                          <a:cs typeface="Arial" pitchFamily="34" charset="-120"/>
-                        </a:rPr>
-                        <a:t>45m</a:t>
-                      </a:r>
-                      <a:endParaRPr lang="en-US" sz="650" dirty="0">
-                        <a:latin typeface="Arial" charset="0"/>
-                        <a:ea typeface="Arial" charset="0"/>
-                        <a:cs typeface="Arial" charset="0"/>
-                      </a:endParaRPr>
-                    </a:p>
-                  </a:txBody>
-                  <a:tcPr marL="38100" marR="38100" marT="25400" marB="25400">
-                    <a:lnL w="6350" cap="flat" cmpd="sng" algn="ctr">
-                      <a:solidFill>
-                        <a:srgbClr val="666666"/>
-                      </a:solidFill>
-                      <a:prstDash val="solid"/>
-                      <a:round/>
-                      <a:headEnd type="none" w="med" len="med"/>
-                      <a:tailEnd type="none" w="med" len="med"/>
-                    </a:lnL>
-                    <a:lnR w="6350" cap="flat" cmpd="sng" algn="ctr">
-                      <a:solidFill>
-                        <a:srgbClr val="666666"/>
-                      </a:solidFill>
-                      <a:prstDash val="solid"/>
-                      <a:round/>
-                      <a:headEnd type="none" w="med" len="med"/>
-                      <a:tailEnd type="none" w="med" len="med"/>
-                    </a:lnR>
-                    <a:lnT w="6350" cap="flat" cmpd="sng" algn="ctr">
-                      <a:solidFill>
-                        <a:srgbClr val="666666"/>
-                      </a:solidFill>
-                      <a:prstDash val="solid"/>
-                      <a:round/>
-                      <a:headEnd type="none" w="med" len="med"/>
-                      <a:tailEnd type="none" w="med" len="med"/>
-                    </a:lnT>
-                    <a:lnB w="6350" cap="flat" cmpd="sng" algn="ctr">
-                      <a:solidFill>
-                        <a:srgbClr val="666666"/>
-                      </a:solidFill>
-                      <a:prstDash val="solid"/>
-                      <a:round/>
-                      <a:headEnd type="none" w="med" len="med"/>
-                      <a:tailEnd type="none" w="med" len="med"/>
-                    </a:lnB>
-                  </a:tcPr>
-                </a:tc>
-              </a:tr>
-              <a:tr h="137160">
-                <a:tc>
-                  <a:txBody>
-                    <a:bodyPr/>
-                    <a:lstStyle/>
-                    <a:p>
-                      <a:pPr indent="0" marL="0">
-                        <a:buNone/>
-                      </a:pPr>
-                      <a:r>
-                        <a:rPr lang="en-US" sz="650" b="1" dirty="0">
-                          <a:solidFill>
-                            <a:srgbClr val="334155"/>
-                          </a:solidFill>
-                          <a:latin typeface="Arial" pitchFamily="34" charset="0"/>
-                          <a:ea typeface="Arial" pitchFamily="34" charset="-122"/>
-                          <a:cs typeface="Arial" pitchFamily="34" charset="-120"/>
-                        </a:rPr>
-                        <a:t>15:15</a:t>
-                      </a:r>
-                      <a:endParaRPr lang="en-US" sz="650" dirty="0">
-                        <a:latin typeface="Arial" charset="0"/>
-                        <a:ea typeface="Arial" charset="0"/>
-                        <a:cs typeface="Arial" charset="0"/>
-                      </a:endParaRPr>
-                    </a:p>
-                  </a:txBody>
-                  <a:tcPr marL="38100" marR="38100" marT="25400" marB="25400">
-                    <a:lnL w="6350" cap="flat" cmpd="sng" algn="ctr">
-                      <a:solidFill>
-                        <a:srgbClr val="666666"/>
-                      </a:solidFill>
-                      <a:prstDash val="solid"/>
-                      <a:round/>
-                      <a:headEnd type="none" w="med" len="med"/>
-                      <a:tailEnd type="none" w="med" len="med"/>
-                    </a:lnL>
-                    <a:lnR w="6350" cap="flat" cmpd="sng" algn="ctr">
-                      <a:solidFill>
-                        <a:srgbClr val="666666"/>
-                      </a:solidFill>
-                      <a:prstDash val="solid"/>
-                      <a:round/>
-                      <a:headEnd type="none" w="med" len="med"/>
-                      <a:tailEnd type="none" w="med" len="med"/>
-                    </a:lnR>
-                    <a:lnT w="6350" cap="flat" cmpd="sng" algn="ctr">
-                      <a:solidFill>
-                        <a:srgbClr val="666666"/>
-                      </a:solidFill>
-                      <a:prstDash val="solid"/>
-                      <a:round/>
-                      <a:headEnd type="none" w="med" len="med"/>
-                      <a:tailEnd type="none" w="med" len="med"/>
-                    </a:lnT>
-                    <a:lnB w="6350" cap="flat" cmpd="sng" algn="ctr">
-                      <a:solidFill>
-                        <a:srgbClr val="666666"/>
-                      </a:solidFill>
-                      <a:prstDash val="solid"/>
-                      <a:round/>
-                      <a:headEnd type="none" w="med" len="med"/>
-                      <a:tailEnd type="none" w="med" len="med"/>
-                    </a:lnB>
-                  </a:tcPr>
-                </a:tc>
-                <a:tc>
-                  <a:txBody>
-                    <a:bodyPr/>
-                    <a:lstStyle/>
-                    <a:p>
-                      <a:pPr indent="0" marL="0">
-                        <a:buNone/>
-                      </a:pPr>
-                      <a:r>
-                        <a:rPr lang="en-US" sz="650" dirty="0">
-                          <a:solidFill>
-                            <a:srgbClr val="334155"/>
-                          </a:solidFill>
-                          <a:latin typeface="Arial" pitchFamily="34" charset="0"/>
-                          <a:ea typeface="Arial" pitchFamily="34" charset="-122"/>
-                          <a:cs typeface="Arial" pitchFamily="34" charset="-120"/>
-                        </a:rPr>
-                        <a:t>休息</a:t>
-                      </a:r>
-                      <a:endParaRPr lang="en-US" sz="650" dirty="0">
-                        <a:latin typeface="Arial" charset="0"/>
-                        <a:ea typeface="Arial" charset="0"/>
-                        <a:cs typeface="Arial" charset="0"/>
-                      </a:endParaRPr>
-                    </a:p>
-                  </a:txBody>
-                  <a:tcPr marL="38100" marR="38100" marT="25400" marB="25400">
-                    <a:lnL w="6350" cap="flat" cmpd="sng" algn="ctr">
-                      <a:solidFill>
-                        <a:srgbClr val="666666"/>
-                      </a:solidFill>
-                      <a:prstDash val="solid"/>
-                      <a:round/>
-                      <a:headEnd type="none" w="med" len="med"/>
-                      <a:tailEnd type="none" w="med" len="med"/>
-                    </a:lnL>
-                    <a:lnR w="6350" cap="flat" cmpd="sng" algn="ctr">
-                      <a:solidFill>
-                        <a:srgbClr val="666666"/>
-                      </a:solidFill>
-                      <a:prstDash val="solid"/>
-                      <a:round/>
-                      <a:headEnd type="none" w="med" len="med"/>
-                      <a:tailEnd type="none" w="med" len="med"/>
-                    </a:lnR>
-                    <a:lnT w="6350" cap="flat" cmpd="sng" algn="ctr">
-                      <a:solidFill>
-                        <a:srgbClr val="666666"/>
-                      </a:solidFill>
-                      <a:prstDash val="solid"/>
-                      <a:round/>
-                      <a:headEnd type="none" w="med" len="med"/>
-                      <a:tailEnd type="none" w="med" len="med"/>
-                    </a:lnT>
-                    <a:lnB w="6350" cap="flat" cmpd="sng" algn="ctr">
-                      <a:solidFill>
-                        <a:srgbClr val="666666"/>
-                      </a:solidFill>
-                      <a:prstDash val="solid"/>
-                      <a:round/>
-                      <a:headEnd type="none" w="med" len="med"/>
-                      <a:tailEnd type="none" w="med" len="med"/>
-                    </a:lnB>
-                  </a:tcPr>
-                </a:tc>
-                <a:tc>
-                  <a:txBody>
-                    <a:bodyPr/>
-                    <a:lstStyle/>
-                    <a:p>
-                      <a:pPr indent="0" marL="0">
-                        <a:buNone/>
-                      </a:pPr>
-                      <a:r>
-                        <a:rPr lang="en-US" sz="650" dirty="0">
-                          <a:solidFill>
-                            <a:srgbClr val="334155"/>
-                          </a:solidFill>
-                          <a:latin typeface="Arial" pitchFamily="34" charset="0"/>
-                          <a:ea typeface="Arial" pitchFamily="34" charset="-122"/>
-                          <a:cs typeface="Arial" pitchFamily="34" charset="-120"/>
-                        </a:rPr>
-                        <a:t>-</a:t>
-                      </a:r>
-                      <a:endParaRPr lang="en-US" sz="650" dirty="0">
-                        <a:latin typeface="Arial" charset="0"/>
-                        <a:ea typeface="Arial" charset="0"/>
-                        <a:cs typeface="Arial" charset="0"/>
-                      </a:endParaRPr>
-                    </a:p>
-                  </a:txBody>
-                  <a:tcPr marL="38100" marR="38100" marT="25400" marB="25400">
-                    <a:lnL w="6350" cap="flat" cmpd="sng" algn="ctr">
-                      <a:solidFill>
-                        <a:srgbClr val="666666"/>
-                      </a:solidFill>
-                      <a:prstDash val="solid"/>
-                      <a:round/>
-                      <a:headEnd type="none" w="med" len="med"/>
-                      <a:tailEnd type="none" w="med" len="med"/>
-                    </a:lnL>
-                    <a:lnR w="6350" cap="flat" cmpd="sng" algn="ctr">
-                      <a:solidFill>
-                        <a:srgbClr val="666666"/>
-                      </a:solidFill>
-                      <a:prstDash val="solid"/>
-                      <a:round/>
-                      <a:headEnd type="none" w="med" len="med"/>
-                      <a:tailEnd type="none" w="med" len="med"/>
-                    </a:lnR>
-                    <a:lnT w="6350" cap="flat" cmpd="sng" algn="ctr">
-                      <a:solidFill>
-                        <a:srgbClr val="666666"/>
-                      </a:solidFill>
-                      <a:prstDash val="solid"/>
-                      <a:round/>
-                      <a:headEnd type="none" w="med" len="med"/>
-                      <a:tailEnd type="none" w="med" len="med"/>
-                    </a:lnT>
-                    <a:lnB w="6350" cap="flat" cmpd="sng" algn="ctr">
-                      <a:solidFill>
-                        <a:srgbClr val="666666"/>
-                      </a:solidFill>
-                      <a:prstDash val="solid"/>
-                      <a:round/>
-                      <a:headEnd type="none" w="med" len="med"/>
-                      <a:tailEnd type="none" w="med" len="med"/>
-                    </a:lnB>
-                  </a:tcPr>
-                </a:tc>
-              </a:tr>
-              <a:tr h="137160">
-                <a:tc>
-                  <a:txBody>
-                    <a:bodyPr/>
-                    <a:lstStyle/>
-                    <a:p>
-                      <a:pPr indent="0" marL="0">
-                        <a:buNone/>
-                      </a:pPr>
-                      <a:r>
-                        <a:rPr lang="en-US" sz="650" b="1" dirty="0">
-                          <a:solidFill>
-                            <a:srgbClr val="334155"/>
-                          </a:solidFill>
-                          <a:latin typeface="Arial" pitchFamily="34" charset="0"/>
-                          <a:ea typeface="Arial" pitchFamily="34" charset="-122"/>
-                          <a:cs typeface="Arial" pitchFamily="34" charset="-120"/>
-                        </a:rPr>
-                        <a:t>15:30</a:t>
-                      </a:r>
-                      <a:endParaRPr lang="en-US" sz="650" dirty="0">
-                        <a:latin typeface="Arial" charset="0"/>
-                        <a:ea typeface="Arial" charset="0"/>
-                        <a:cs typeface="Arial" charset="0"/>
-                      </a:endParaRPr>
-                    </a:p>
-                  </a:txBody>
-                  <a:tcPr marL="38100" marR="38100" marT="25400" marB="25400">
-                    <a:lnL w="6350" cap="flat" cmpd="sng" algn="ctr">
-                      <a:solidFill>
-                        <a:srgbClr val="666666"/>
-                      </a:solidFill>
-                      <a:prstDash val="solid"/>
-                      <a:round/>
-                      <a:headEnd type="none" w="med" len="med"/>
-                      <a:tailEnd type="none" w="med" len="med"/>
-                    </a:lnL>
-                    <a:lnR w="6350" cap="flat" cmpd="sng" algn="ctr">
-                      <a:solidFill>
-                        <a:srgbClr val="666666"/>
-                      </a:solidFill>
-                      <a:prstDash val="solid"/>
-                      <a:round/>
-                      <a:headEnd type="none" w="med" len="med"/>
-                      <a:tailEnd type="none" w="med" len="med"/>
-                    </a:lnR>
-                    <a:lnT w="6350" cap="flat" cmpd="sng" algn="ctr">
-                      <a:solidFill>
-                        <a:srgbClr val="666666"/>
-                      </a:solidFill>
-                      <a:prstDash val="solid"/>
-                      <a:round/>
-                      <a:headEnd type="none" w="med" len="med"/>
-                      <a:tailEnd type="none" w="med" len="med"/>
-                    </a:lnT>
-                    <a:lnB w="6350" cap="flat" cmpd="sng" algn="ctr">
-                      <a:solidFill>
-                        <a:srgbClr val="666666"/>
-                      </a:solidFill>
-                      <a:prstDash val="solid"/>
-                      <a:round/>
-                      <a:headEnd type="none" w="med" len="med"/>
-                      <a:tailEnd type="none" w="med" len="med"/>
-                    </a:lnB>
-                  </a:tcPr>
-                </a:tc>
-                <a:tc>
-                  <a:txBody>
-                    <a:bodyPr/>
-                    <a:lstStyle/>
-                    <a:p>
-                      <a:pPr indent="0" marL="0">
-                        <a:buNone/>
-                      </a:pPr>
-                      <a:r>
-                        <a:rPr lang="en-US" sz="650" dirty="0">
-                          <a:solidFill>
-                            <a:srgbClr val="334155"/>
-                          </a:solidFill>
-                          <a:latin typeface="Arial" pitchFamily="34" charset="0"/>
-                          <a:ea typeface="Arial" pitchFamily="34" charset="-122"/>
-                          <a:cs typeface="Arial" pitchFamily="34" charset="-120"/>
-                        </a:rPr>
-                        <a:t>W1练手</a:t>
+                        <a:t>W1实战</a:t>
                       </a:r>
                       <a:endParaRPr lang="en-US" sz="650" dirty="0">
                         <a:latin typeface="Arial" charset="0"/>
@@ -14279,7 +13713,7 @@
                   </a:tcPr>
                 </a:tc>
               </a:tr>
-              <a:tr h="137160">
+              <a:tr h="164592">
                 <a:tc>
                   <a:txBody>
                     <a:bodyPr/>
@@ -14297,7 +13731,7 @@
                           <a:ea typeface="Arial" pitchFamily="34" charset="-122"/>
                           <a:cs typeface="Arial" pitchFamily="34" charset="-120"/>
                         </a:rPr>
-                        <a:t>16:30</a:t>
+                        <a:t>15:30</a:t>
                       </a:r>
                       <a:endParaRPr lang="en-US" sz="650" dirty="0">
                         <a:latin typeface="Arial" charset="0"/>
@@ -14476,7 +13910,7 @@
                   </a:tcPr>
                 </a:tc>
               </a:tr>
-              <a:tr h="137160">
+              <a:tr h="164592">
                 <a:tc>
                   <a:txBody>
                     <a:bodyPr/>
@@ -14494,7 +13928,7 @@
                           <a:ea typeface="Arial" pitchFamily="34" charset="-122"/>
                           <a:cs typeface="Arial" pitchFamily="34" charset="-120"/>
                         </a:rPr>
-                        <a:t>16:40</a:t>
+                        <a:t>15:45</a:t>
                       </a:r>
                       <a:endParaRPr lang="en-US" sz="650" dirty="0">
                         <a:latin typeface="Arial" charset="0"/>
@@ -14559,7 +13993,7 @@
                           <a:ea typeface="Arial" pitchFamily="34" charset="-122"/>
                           <a:cs typeface="Arial" pitchFamily="34" charset="-120"/>
                         </a:rPr>
-                        <a:t>L3 Live</a:t>
+                        <a:t>L3推演</a:t>
                       </a:r>
                       <a:endParaRPr lang="en-US" sz="650" dirty="0">
                         <a:latin typeface="Arial" charset="0"/>
@@ -14627,7 +14061,7 @@
                           <a:ea typeface="Arial" pitchFamily="34" charset="-122"/>
                           <a:cs typeface="Arial" pitchFamily="34" charset="-120"/>
                         </a:rPr>
-                        <a:t>60m</a:t>
+                        <a:t>105m</a:t>
                       </a:r>
                       <a:endParaRPr lang="en-US" sz="650" dirty="0">
                         <a:latin typeface="Arial" charset="0"/>
@@ -14676,7 +14110,7 @@
                   </a:tcPr>
                 </a:tc>
               </a:tr>
-              <a:tr h="137160">
+              <a:tr h="164592">
                 <a:tc>
                   <a:txBody>
                     <a:bodyPr/>
@@ -14694,7 +14128,7 @@
                           <a:ea typeface="Arial" pitchFamily="34" charset="-122"/>
                           <a:cs typeface="Arial" pitchFamily="34" charset="-120"/>
                         </a:rPr>
-                        <a:t>17:40</a:t>
+                        <a:t>17:30</a:t>
                       </a:r>
                       <a:endParaRPr lang="en-US" sz="650" dirty="0">
                         <a:latin typeface="Arial" charset="0"/>
@@ -14827,7 +14261,7 @@
                           <a:ea typeface="Arial" pitchFamily="34" charset="-122"/>
                           <a:cs typeface="Arial" pitchFamily="34" charset="-120"/>
                         </a:rPr>
-                        <a:t>20m</a:t>
+                        <a:t>30m</a:t>
                       </a:r>
                       <a:endParaRPr lang="en-US" sz="650" dirty="0">
                         <a:latin typeface="Arial" charset="0"/>
@@ -14943,7 +14377,7 @@
                 <a:gridCol w="1188720"/>
                 <a:gridCol w="411480"/>
               </a:tblGrid>
-              <a:tr h="150876">
+              <a:tr h="164592">
                 <a:tc>
                   <a:txBody>
                     <a:bodyPr/>
@@ -15149,7 +14583,7 @@
                   </a:tcPr>
                 </a:tc>
               </a:tr>
-              <a:tr h="150876">
+              <a:tr h="164592">
                 <a:tc>
                   <a:txBody>
                     <a:bodyPr/>
@@ -15349,7 +14783,7 @@
                   </a:tcPr>
                 </a:tc>
               </a:tr>
-              <a:tr h="150876">
+              <a:tr h="164592">
                 <a:tc>
                   <a:txBody>
                     <a:bodyPr/>
@@ -15546,7 +14980,7 @@
                   </a:tcPr>
                 </a:tc>
               </a:tr>
-              <a:tr h="150876">
+              <a:tr h="164592">
                 <a:tc>
                   <a:txBody>
                     <a:bodyPr/>
@@ -15565,6 +14999,206 @@
                           <a:cs typeface="Arial" pitchFamily="34" charset="-120"/>
                         </a:rPr>
                         <a:t>11:00</a:t>
+                      </a:r>
+                      <a:endParaRPr lang="en-US" sz="650" dirty="0">
+                        <a:latin typeface="Arial" charset="0"/>
+                        <a:ea typeface="Arial" charset="0"/>
+                        <a:cs typeface="Arial" charset="0"/>
+                      </a:endParaRPr>
+                    </a:p>
+                  </a:txBody>
+                  <a:tcPr marL="38100" marR="38100" marT="25400" marB="25400">
+                    <a:lnL w="6350" cap="flat" cmpd="sng" algn="ctr">
+                      <a:solidFill>
+                        <a:srgbClr val="666666"/>
+                      </a:solidFill>
+                      <a:prstDash val="solid"/>
+                      <a:round/>
+                      <a:headEnd type="none" w="med" len="med"/>
+                      <a:tailEnd type="none" w="med" len="med"/>
+                    </a:lnL>
+                    <a:lnR w="6350" cap="flat" cmpd="sng" algn="ctr">
+                      <a:solidFill>
+                        <a:srgbClr val="666666"/>
+                      </a:solidFill>
+                      <a:prstDash val="solid"/>
+                      <a:round/>
+                      <a:headEnd type="none" w="med" len="med"/>
+                      <a:tailEnd type="none" w="med" len="med"/>
+                    </a:lnR>
+                    <a:lnT w="6350" cap="flat" cmpd="sng" algn="ctr">
+                      <a:solidFill>
+                        <a:srgbClr val="666666"/>
+                      </a:solidFill>
+                      <a:prstDash val="solid"/>
+                      <a:round/>
+                      <a:headEnd type="none" w="med" len="med"/>
+                      <a:tailEnd type="none" w="med" len="med"/>
+                    </a:lnT>
+                    <a:lnB w="6350" cap="flat" cmpd="sng" algn="ctr">
+                      <a:solidFill>
+                        <a:srgbClr val="666666"/>
+                      </a:solidFill>
+                      <a:prstDash val="solid"/>
+                      <a:round/>
+                      <a:headEnd type="none" w="med" len="med"/>
+                      <a:tailEnd type="none" w="med" len="med"/>
+                    </a:lnB>
+                  </a:tcPr>
+                </a:tc>
+                <a:tc>
+                  <a:txBody>
+                    <a:bodyPr/>
+                    <a:lstStyle/>
+                    <a:p>
+                      <a:pPr indent="0" marL="0">
+                        <a:buNone/>
+                      </a:pPr>
+                      <a:r>
+                        <a:rPr lang="en-US" sz="650" dirty="0">
+                          <a:solidFill>
+                            <a:srgbClr val="334155"/>
+                          </a:solidFill>
+                          <a:latin typeface="Arial" pitchFamily="34" charset="0"/>
+                          <a:ea typeface="Arial" pitchFamily="34" charset="-122"/>
+                          <a:cs typeface="Arial" pitchFamily="34" charset="-120"/>
+                        </a:rPr>
+                        <a:t>W2实操</a:t>
+                      </a:r>
+                      <a:endParaRPr lang="en-US" sz="650" dirty="0">
+                        <a:latin typeface="Arial" charset="0"/>
+                        <a:ea typeface="Arial" charset="0"/>
+                        <a:cs typeface="Arial" charset="0"/>
+                      </a:endParaRPr>
+                    </a:p>
+                  </a:txBody>
+                  <a:tcPr marL="38100" marR="38100" marT="25400" marB="25400">
+                    <a:lnL w="6350" cap="flat" cmpd="sng" algn="ctr">
+                      <a:solidFill>
+                        <a:srgbClr val="666666"/>
+                      </a:solidFill>
+                      <a:prstDash val="solid"/>
+                      <a:round/>
+                      <a:headEnd type="none" w="med" len="med"/>
+                      <a:tailEnd type="none" w="med" len="med"/>
+                    </a:lnL>
+                    <a:lnR w="6350" cap="flat" cmpd="sng" algn="ctr">
+                      <a:solidFill>
+                        <a:srgbClr val="666666"/>
+                      </a:solidFill>
+                      <a:prstDash val="solid"/>
+                      <a:round/>
+                      <a:headEnd type="none" w="med" len="med"/>
+                      <a:tailEnd type="none" w="med" len="med"/>
+                    </a:lnR>
+                    <a:lnT w="6350" cap="flat" cmpd="sng" algn="ctr">
+                      <a:solidFill>
+                        <a:srgbClr val="666666"/>
+                      </a:solidFill>
+                      <a:prstDash val="solid"/>
+                      <a:round/>
+                      <a:headEnd type="none" w="med" len="med"/>
+                      <a:tailEnd type="none" w="med" len="med"/>
+                    </a:lnT>
+                    <a:lnB w="6350" cap="flat" cmpd="sng" algn="ctr">
+                      <a:solidFill>
+                        <a:srgbClr val="666666"/>
+                      </a:solidFill>
+                      <a:prstDash val="solid"/>
+                      <a:round/>
+                      <a:headEnd type="none" w="med" len="med"/>
+                      <a:tailEnd type="none" w="med" len="med"/>
+                    </a:lnB>
+                    <a:solidFill>
+                      <a:srgbClr val="FFF7ED"/>
+                    </a:solidFill>
+                  </a:tcPr>
+                </a:tc>
+                <a:tc>
+                  <a:txBody>
+                    <a:bodyPr/>
+                    <a:lstStyle/>
+                    <a:p>
+                      <a:pPr indent="0" marL="0">
+                        <a:buNone/>
+                      </a:pPr>
+                      <a:r>
+                        <a:rPr lang="en-US" sz="650" dirty="0">
+                          <a:solidFill>
+                            <a:srgbClr val="334155"/>
+                          </a:solidFill>
+                          <a:latin typeface="Arial" pitchFamily="34" charset="0"/>
+                          <a:ea typeface="Arial" pitchFamily="34" charset="-122"/>
+                          <a:cs typeface="Arial" pitchFamily="34" charset="-120"/>
+                        </a:rPr>
+                        <a:t>75m</a:t>
+                      </a:r>
+                      <a:endParaRPr lang="en-US" sz="650" dirty="0">
+                        <a:latin typeface="Arial" charset="0"/>
+                        <a:ea typeface="Arial" charset="0"/>
+                        <a:cs typeface="Arial" charset="0"/>
+                      </a:endParaRPr>
+                    </a:p>
+                  </a:txBody>
+                  <a:tcPr marL="38100" marR="38100" marT="25400" marB="25400">
+                    <a:lnL w="6350" cap="flat" cmpd="sng" algn="ctr">
+                      <a:solidFill>
+                        <a:srgbClr val="666666"/>
+                      </a:solidFill>
+                      <a:prstDash val="solid"/>
+                      <a:round/>
+                      <a:headEnd type="none" w="med" len="med"/>
+                      <a:tailEnd type="none" w="med" len="med"/>
+                    </a:lnL>
+                    <a:lnR w="6350" cap="flat" cmpd="sng" algn="ctr">
+                      <a:solidFill>
+                        <a:srgbClr val="666666"/>
+                      </a:solidFill>
+                      <a:prstDash val="solid"/>
+                      <a:round/>
+                      <a:headEnd type="none" w="med" len="med"/>
+                      <a:tailEnd type="none" w="med" len="med"/>
+                    </a:lnR>
+                    <a:lnT w="6350" cap="flat" cmpd="sng" algn="ctr">
+                      <a:solidFill>
+                        <a:srgbClr val="666666"/>
+                      </a:solidFill>
+                      <a:prstDash val="solid"/>
+                      <a:round/>
+                      <a:headEnd type="none" w="med" len="med"/>
+                      <a:tailEnd type="none" w="med" len="med"/>
+                    </a:lnT>
+                    <a:lnB w="6350" cap="flat" cmpd="sng" algn="ctr">
+                      <a:solidFill>
+                        <a:srgbClr val="666666"/>
+                      </a:solidFill>
+                      <a:prstDash val="solid"/>
+                      <a:round/>
+                      <a:headEnd type="none" w="med" len="med"/>
+                      <a:tailEnd type="none" w="med" len="med"/>
+                    </a:lnB>
+                  </a:tcPr>
+                </a:tc>
+              </a:tr>
+              <a:tr h="164592">
+                <a:tc>
+                  <a:txBody>
+                    <a:bodyPr/>
+                    <a:lstStyle/>
+                    <a:p>
+                      <a:pPr indent="0" marL="0">
+                        <a:buNone/>
+                      </a:pPr>
+                      <a:r>
+                        <a:rPr lang="en-US" sz="650" b="1" dirty="0">
+                          <a:solidFill>
+                            <a:srgbClr val="334155"/>
+                          </a:solidFill>
+                          <a:latin typeface="Arial" pitchFamily="34" charset="0"/>
+                          <a:ea typeface="Arial" pitchFamily="34" charset="-122"/>
+                          <a:cs typeface="Arial" pitchFamily="34" charset="-120"/>
+                        </a:rPr>
+                        <a:t>14:30</a:t>
                       </a:r>
                       <a:endParaRPr lang="en-US" sz="650" dirty="0">
                         <a:latin typeface="Arial" charset="0"/>
@@ -15746,7 +15380,7 @@
                   </a:tcPr>
                 </a:tc>
               </a:tr>
-              <a:tr h="150876">
+              <a:tr h="164592">
                 <a:tc>
                   <a:txBody>
                     <a:bodyPr/>
@@ -15764,7 +15398,7 @@
                           <a:ea typeface="Arial" pitchFamily="34" charset="-122"/>
                           <a:cs typeface="Arial" pitchFamily="34" charset="-120"/>
                         </a:rPr>
-                        <a:t>11:50</a:t>
+                        <a:t>15:20</a:t>
                       </a:r>
                       <a:endParaRPr lang="en-US" sz="650" dirty="0">
                         <a:latin typeface="Arial" charset="0"/>
@@ -15829,7 +15463,7 @@
                           <a:ea typeface="Arial" pitchFamily="34" charset="-122"/>
                           <a:cs typeface="Arial" pitchFamily="34" charset="-120"/>
                         </a:rPr>
-                        <a:t>午餐</a:t>
+                        <a:t>休息</a:t>
                       </a:r>
                       <a:endParaRPr lang="en-US" sz="650" dirty="0">
                         <a:latin typeface="Arial" charset="0"/>
@@ -15943,7 +15577,7 @@
                   </a:tcPr>
                 </a:tc>
               </a:tr>
-              <a:tr h="150876">
+              <a:tr h="164592">
                 <a:tc>
                   <a:txBody>
                     <a:bodyPr/>
@@ -15961,404 +15595,7 @@
                           <a:ea typeface="Arial" pitchFamily="34" charset="-122"/>
                           <a:cs typeface="Arial" pitchFamily="34" charset="-120"/>
                         </a:rPr>
-                        <a:t>14:30</a:t>
-                      </a:r>
-                      <a:endParaRPr lang="en-US" sz="650" dirty="0">
-                        <a:latin typeface="Arial" charset="0"/>
-                        <a:ea typeface="Arial" charset="0"/>
-                        <a:cs typeface="Arial" charset="0"/>
-                      </a:endParaRPr>
-                    </a:p>
-                  </a:txBody>
-                  <a:tcPr marL="38100" marR="38100" marT="25400" marB="25400">
-                    <a:lnL w="6350" cap="flat" cmpd="sng" algn="ctr">
-                      <a:solidFill>
-                        <a:srgbClr val="666666"/>
-                      </a:solidFill>
-                      <a:prstDash val="solid"/>
-                      <a:round/>
-                      <a:headEnd type="none" w="med" len="med"/>
-                      <a:tailEnd type="none" w="med" len="med"/>
-                    </a:lnL>
-                    <a:lnR w="6350" cap="flat" cmpd="sng" algn="ctr">
-                      <a:solidFill>
-                        <a:srgbClr val="666666"/>
-                      </a:solidFill>
-                      <a:prstDash val="solid"/>
-                      <a:round/>
-                      <a:headEnd type="none" w="med" len="med"/>
-                      <a:tailEnd type="none" w="med" len="med"/>
-                    </a:lnR>
-                    <a:lnT w="6350" cap="flat" cmpd="sng" algn="ctr">
-                      <a:solidFill>
-                        <a:srgbClr val="666666"/>
-                      </a:solidFill>
-                      <a:prstDash val="solid"/>
-                      <a:round/>
-                      <a:headEnd type="none" w="med" len="med"/>
-                      <a:tailEnd type="none" w="med" len="med"/>
-                    </a:lnT>
-                    <a:lnB w="6350" cap="flat" cmpd="sng" algn="ctr">
-                      <a:solidFill>
-                        <a:srgbClr val="666666"/>
-                      </a:solidFill>
-                      <a:prstDash val="solid"/>
-                      <a:round/>
-                      <a:headEnd type="none" w="med" len="med"/>
-                      <a:tailEnd type="none" w="med" len="med"/>
-                    </a:lnB>
-                  </a:tcPr>
-                </a:tc>
-                <a:tc>
-                  <a:txBody>
-                    <a:bodyPr/>
-                    <a:lstStyle/>
-                    <a:p>
-                      <a:pPr indent="0" marL="0">
-                        <a:buNone/>
-                      </a:pPr>
-                      <a:r>
-                        <a:rPr lang="en-US" sz="650" dirty="0">
-                          <a:solidFill>
-                            <a:srgbClr val="334155"/>
-                          </a:solidFill>
-                          <a:latin typeface="Arial" pitchFamily="34" charset="0"/>
-                          <a:ea typeface="Arial" pitchFamily="34" charset="-122"/>
-                          <a:cs typeface="Arial" pitchFamily="34" charset="-120"/>
-                        </a:rPr>
-                        <a:t>W2重构</a:t>
-                      </a:r>
-                      <a:endParaRPr lang="en-US" sz="650" dirty="0">
-                        <a:latin typeface="Arial" charset="0"/>
-                        <a:ea typeface="Arial" charset="0"/>
-                        <a:cs typeface="Arial" charset="0"/>
-                      </a:endParaRPr>
-                    </a:p>
-                  </a:txBody>
-                  <a:tcPr marL="38100" marR="38100" marT="25400" marB="25400">
-                    <a:lnL w="6350" cap="flat" cmpd="sng" algn="ctr">
-                      <a:solidFill>
-                        <a:srgbClr val="666666"/>
-                      </a:solidFill>
-                      <a:prstDash val="solid"/>
-                      <a:round/>
-                      <a:headEnd type="none" w="med" len="med"/>
-                      <a:tailEnd type="none" w="med" len="med"/>
-                    </a:lnL>
-                    <a:lnR w="6350" cap="flat" cmpd="sng" algn="ctr">
-                      <a:solidFill>
-                        <a:srgbClr val="666666"/>
-                      </a:solidFill>
-                      <a:prstDash val="solid"/>
-                      <a:round/>
-                      <a:headEnd type="none" w="med" len="med"/>
-                      <a:tailEnd type="none" w="med" len="med"/>
-                    </a:lnR>
-                    <a:lnT w="6350" cap="flat" cmpd="sng" algn="ctr">
-                      <a:solidFill>
-                        <a:srgbClr val="666666"/>
-                      </a:solidFill>
-                      <a:prstDash val="solid"/>
-                      <a:round/>
-                      <a:headEnd type="none" w="med" len="med"/>
-                      <a:tailEnd type="none" w="med" len="med"/>
-                    </a:lnT>
-                    <a:lnB w="6350" cap="flat" cmpd="sng" algn="ctr">
-                      <a:solidFill>
-                        <a:srgbClr val="666666"/>
-                      </a:solidFill>
-                      <a:prstDash val="solid"/>
-                      <a:round/>
-                      <a:headEnd type="none" w="med" len="med"/>
-                      <a:tailEnd type="none" w="med" len="med"/>
-                    </a:lnB>
-                    <a:solidFill>
-                      <a:srgbClr val="FFF7ED"/>
-                    </a:solidFill>
-                  </a:tcPr>
-                </a:tc>
-                <a:tc>
-                  <a:txBody>
-                    <a:bodyPr/>
-                    <a:lstStyle/>
-                    <a:p>
-                      <a:pPr indent="0" marL="0">
-                        <a:buNone/>
-                      </a:pPr>
-                      <a:r>
-                        <a:rPr lang="en-US" sz="650" dirty="0">
-                          <a:solidFill>
-                            <a:srgbClr val="334155"/>
-                          </a:solidFill>
-                          <a:latin typeface="Arial" pitchFamily="34" charset="0"/>
-                          <a:ea typeface="Arial" pitchFamily="34" charset="-122"/>
-                          <a:cs typeface="Arial" pitchFamily="34" charset="-120"/>
-                        </a:rPr>
-                        <a:t>75m</a:t>
-                      </a:r>
-                      <a:endParaRPr lang="en-US" sz="650" dirty="0">
-                        <a:latin typeface="Arial" charset="0"/>
-                        <a:ea typeface="Arial" charset="0"/>
-                        <a:cs typeface="Arial" charset="0"/>
-                      </a:endParaRPr>
-                    </a:p>
-                  </a:txBody>
-                  <a:tcPr marL="38100" marR="38100" marT="25400" marB="25400">
-                    <a:lnL w="6350" cap="flat" cmpd="sng" algn="ctr">
-                      <a:solidFill>
-                        <a:srgbClr val="666666"/>
-                      </a:solidFill>
-                      <a:prstDash val="solid"/>
-                      <a:round/>
-                      <a:headEnd type="none" w="med" len="med"/>
-                      <a:tailEnd type="none" w="med" len="med"/>
-                    </a:lnL>
-                    <a:lnR w="6350" cap="flat" cmpd="sng" algn="ctr">
-                      <a:solidFill>
-                        <a:srgbClr val="666666"/>
-                      </a:solidFill>
-                      <a:prstDash val="solid"/>
-                      <a:round/>
-                      <a:headEnd type="none" w="med" len="med"/>
-                      <a:tailEnd type="none" w="med" len="med"/>
-                    </a:lnR>
-                    <a:lnT w="6350" cap="flat" cmpd="sng" algn="ctr">
-                      <a:solidFill>
-                        <a:srgbClr val="666666"/>
-                      </a:solidFill>
-                      <a:prstDash val="solid"/>
-                      <a:round/>
-                      <a:headEnd type="none" w="med" len="med"/>
-                      <a:tailEnd type="none" w="med" len="med"/>
-                    </a:lnT>
-                    <a:lnB w="6350" cap="flat" cmpd="sng" algn="ctr">
-                      <a:solidFill>
-                        <a:srgbClr val="666666"/>
-                      </a:solidFill>
-                      <a:prstDash val="solid"/>
-                      <a:round/>
-                      <a:headEnd type="none" w="med" len="med"/>
-                      <a:tailEnd type="none" w="med" len="med"/>
-                    </a:lnB>
-                  </a:tcPr>
-                </a:tc>
-              </a:tr>
-              <a:tr h="150876">
-                <a:tc>
-                  <a:txBody>
-                    <a:bodyPr/>
-                    <a:lstStyle/>
-                    <a:p>
-                      <a:pPr indent="0" marL="0">
-                        <a:buNone/>
-                      </a:pPr>
-                      <a:r>
-                        <a:rPr lang="en-US" sz="650" b="1" dirty="0">
-                          <a:solidFill>
-                            <a:srgbClr val="334155"/>
-                          </a:solidFill>
-                          <a:latin typeface="Arial" pitchFamily="34" charset="0"/>
-                          <a:ea typeface="Arial" pitchFamily="34" charset="-122"/>
-                          <a:cs typeface="Arial" pitchFamily="34" charset="-120"/>
-                        </a:rPr>
-                        <a:t>15:45</a:t>
-                      </a:r>
-                      <a:endParaRPr lang="en-US" sz="650" dirty="0">
-                        <a:latin typeface="Arial" charset="0"/>
-                        <a:ea typeface="Arial" charset="0"/>
-                        <a:cs typeface="Arial" charset="0"/>
-                      </a:endParaRPr>
-                    </a:p>
-                  </a:txBody>
-                  <a:tcPr marL="38100" marR="38100" marT="25400" marB="25400">
-                    <a:lnL w="6350" cap="flat" cmpd="sng" algn="ctr">
-                      <a:solidFill>
-                        <a:srgbClr val="666666"/>
-                      </a:solidFill>
-                      <a:prstDash val="solid"/>
-                      <a:round/>
-                      <a:headEnd type="none" w="med" len="med"/>
-                      <a:tailEnd type="none" w="med" len="med"/>
-                    </a:lnL>
-                    <a:lnR w="6350" cap="flat" cmpd="sng" algn="ctr">
-                      <a:solidFill>
-                        <a:srgbClr val="666666"/>
-                      </a:solidFill>
-                      <a:prstDash val="solid"/>
-                      <a:round/>
-                      <a:headEnd type="none" w="med" len="med"/>
-                      <a:tailEnd type="none" w="med" len="med"/>
-                    </a:lnR>
-                    <a:lnT w="6350" cap="flat" cmpd="sng" algn="ctr">
-                      <a:solidFill>
-                        <a:srgbClr val="666666"/>
-                      </a:solidFill>
-                      <a:prstDash val="solid"/>
-                      <a:round/>
-                      <a:headEnd type="none" w="med" len="med"/>
-                      <a:tailEnd type="none" w="med" len="med"/>
-                    </a:lnT>
-                    <a:lnB w="6350" cap="flat" cmpd="sng" algn="ctr">
-                      <a:solidFill>
-                        <a:srgbClr val="666666"/>
-                      </a:solidFill>
-                      <a:prstDash val="solid"/>
-                      <a:round/>
-                      <a:headEnd type="none" w="med" len="med"/>
-                      <a:tailEnd type="none" w="med" len="med"/>
-                    </a:lnB>
-                  </a:tcPr>
-                </a:tc>
-                <a:tc>
-                  <a:txBody>
-                    <a:bodyPr/>
-                    <a:lstStyle/>
-                    <a:p>
-                      <a:pPr indent="0" marL="0">
-                        <a:buNone/>
-                      </a:pPr>
-                      <a:r>
-                        <a:rPr lang="en-US" sz="650" dirty="0">
-                          <a:solidFill>
-                            <a:srgbClr val="334155"/>
-                          </a:solidFill>
-                          <a:latin typeface="Arial" pitchFamily="34" charset="0"/>
-                          <a:ea typeface="Arial" pitchFamily="34" charset="-122"/>
-                          <a:cs typeface="Arial" pitchFamily="34" charset="-120"/>
-                        </a:rPr>
-                        <a:t>休息</a:t>
-                      </a:r>
-                      <a:endParaRPr lang="en-US" sz="650" dirty="0">
-                        <a:latin typeface="Arial" charset="0"/>
-                        <a:ea typeface="Arial" charset="0"/>
-                        <a:cs typeface="Arial" charset="0"/>
-                      </a:endParaRPr>
-                    </a:p>
-                  </a:txBody>
-                  <a:tcPr marL="38100" marR="38100" marT="25400" marB="25400">
-                    <a:lnL w="6350" cap="flat" cmpd="sng" algn="ctr">
-                      <a:solidFill>
-                        <a:srgbClr val="666666"/>
-                      </a:solidFill>
-                      <a:prstDash val="solid"/>
-                      <a:round/>
-                      <a:headEnd type="none" w="med" len="med"/>
-                      <a:tailEnd type="none" w="med" len="med"/>
-                    </a:lnL>
-                    <a:lnR w="6350" cap="flat" cmpd="sng" algn="ctr">
-                      <a:solidFill>
-                        <a:srgbClr val="666666"/>
-                      </a:solidFill>
-                      <a:prstDash val="solid"/>
-                      <a:round/>
-                      <a:headEnd type="none" w="med" len="med"/>
-                      <a:tailEnd type="none" w="med" len="med"/>
-                    </a:lnR>
-                    <a:lnT w="6350" cap="flat" cmpd="sng" algn="ctr">
-                      <a:solidFill>
-                        <a:srgbClr val="666666"/>
-                      </a:solidFill>
-                      <a:prstDash val="solid"/>
-                      <a:round/>
-                      <a:headEnd type="none" w="med" len="med"/>
-                      <a:tailEnd type="none" w="med" len="med"/>
-                    </a:lnT>
-                    <a:lnB w="6350" cap="flat" cmpd="sng" algn="ctr">
-                      <a:solidFill>
-                        <a:srgbClr val="666666"/>
-                      </a:solidFill>
-                      <a:prstDash val="solid"/>
-                      <a:round/>
-                      <a:headEnd type="none" w="med" len="med"/>
-                      <a:tailEnd type="none" w="med" len="med"/>
-                    </a:lnB>
-                  </a:tcPr>
-                </a:tc>
-                <a:tc>
-                  <a:txBody>
-                    <a:bodyPr/>
-                    <a:lstStyle/>
-                    <a:p>
-                      <a:pPr indent="0" marL="0">
-                        <a:buNone/>
-                      </a:pPr>
-                      <a:r>
-                        <a:rPr lang="en-US" sz="650" dirty="0">
-                          <a:solidFill>
-                            <a:srgbClr val="334155"/>
-                          </a:solidFill>
-                          <a:latin typeface="Arial" pitchFamily="34" charset="0"/>
-                          <a:ea typeface="Arial" pitchFamily="34" charset="-122"/>
-                          <a:cs typeface="Arial" pitchFamily="34" charset="-120"/>
-                        </a:rPr>
-                        <a:t>-</a:t>
-                      </a:r>
-                      <a:endParaRPr lang="en-US" sz="650" dirty="0">
-                        <a:latin typeface="Arial" charset="0"/>
-                        <a:ea typeface="Arial" charset="0"/>
-                        <a:cs typeface="Arial" charset="0"/>
-                      </a:endParaRPr>
-                    </a:p>
-                  </a:txBody>
-                  <a:tcPr marL="38100" marR="38100" marT="25400" marB="25400">
-                    <a:lnL w="6350" cap="flat" cmpd="sng" algn="ctr">
-                      <a:solidFill>
-                        <a:srgbClr val="666666"/>
-                      </a:solidFill>
-                      <a:prstDash val="solid"/>
-                      <a:round/>
-                      <a:headEnd type="none" w="med" len="med"/>
-                      <a:tailEnd type="none" w="med" len="med"/>
-                    </a:lnL>
-                    <a:lnR w="6350" cap="flat" cmpd="sng" algn="ctr">
-                      <a:solidFill>
-                        <a:srgbClr val="666666"/>
-                      </a:solidFill>
-                      <a:prstDash val="solid"/>
-                      <a:round/>
-                      <a:headEnd type="none" w="med" len="med"/>
-                      <a:tailEnd type="none" w="med" len="med"/>
-                    </a:lnR>
-                    <a:lnT w="6350" cap="flat" cmpd="sng" algn="ctr">
-                      <a:solidFill>
-                        <a:srgbClr val="666666"/>
-                      </a:solidFill>
-                      <a:prstDash val="solid"/>
-                      <a:round/>
-                      <a:headEnd type="none" w="med" len="med"/>
-                      <a:tailEnd type="none" w="med" len="med"/>
-                    </a:lnT>
-                    <a:lnB w="6350" cap="flat" cmpd="sng" algn="ctr">
-                      <a:solidFill>
-                        <a:srgbClr val="666666"/>
-                      </a:solidFill>
-                      <a:prstDash val="solid"/>
-                      <a:round/>
-                      <a:headEnd type="none" w="med" len="med"/>
-                      <a:tailEnd type="none" w="med" len="med"/>
-                    </a:lnB>
-                  </a:tcPr>
-                </a:tc>
-              </a:tr>
-              <a:tr h="150876">
-                <a:tc>
-                  <a:txBody>
-                    <a:bodyPr/>
-                    <a:lstStyle/>
-                    <a:p>
-                      <a:pPr indent="0" marL="0">
-                        <a:buNone/>
-                      </a:pPr>
-                      <a:r>
-                        <a:rPr lang="en-US" sz="650" b="1" dirty="0">
-                          <a:solidFill>
-                            <a:srgbClr val="334155"/>
-                          </a:solidFill>
-                          <a:latin typeface="Arial" pitchFamily="34" charset="0"/>
-                          <a:ea typeface="Arial" pitchFamily="34" charset="-122"/>
-                          <a:cs typeface="Arial" pitchFamily="34" charset="-120"/>
-                        </a:rPr>
-                        <a:t>16:00</a:t>
+                        <a:t>15:35</a:t>
                       </a:r>
                       <a:endParaRPr lang="en-US" sz="650" dirty="0">
                         <a:latin typeface="Arial" charset="0"/>
@@ -16540,7 +15777,7 @@
                   </a:tcPr>
                 </a:tc>
               </a:tr>
-              <a:tr h="150876">
+              <a:tr h="164592">
                 <a:tc>
                   <a:txBody>
                     <a:bodyPr/>
@@ -16558,7 +15795,7 @@
                           <a:ea typeface="Arial" pitchFamily="34" charset="-122"/>
                           <a:cs typeface="Arial" pitchFamily="34" charset="-120"/>
                         </a:rPr>
-                        <a:t>17:00</a:t>
+                        <a:t>16:35</a:t>
                       </a:r>
                       <a:endParaRPr lang="en-US" sz="650" dirty="0">
                         <a:latin typeface="Arial" charset="0"/>
@@ -16623,7 +15860,7 @@
                           <a:ea typeface="Arial" pitchFamily="34" charset="-122"/>
                           <a:cs typeface="Arial" pitchFamily="34" charset="-120"/>
                         </a:rPr>
-                        <a:t>评审</a:t>
+                        <a:t>总结</a:t>
                       </a:r>
                       <a:endParaRPr lang="en-US" sz="650" dirty="0">
                         <a:latin typeface="Arial" charset="0"/>
@@ -16740,7 +15977,7 @@
                   </a:tcPr>
                 </a:tc>
               </a:tr>
-              <a:tr h="150876">
+              <a:tr h="164592">
                 <a:tc>
                   <a:txBody>
                     <a:bodyPr/>
@@ -16758,7 +15995,7 @@
                           <a:ea typeface="Arial" pitchFamily="34" charset="-122"/>
                           <a:cs typeface="Arial" pitchFamily="34" charset="-120"/>
                         </a:rPr>
-                        <a:t>17:30</a:t>
+                        <a:t>17:05</a:t>
                       </a:r>
                       <a:endParaRPr lang="en-US" sz="650" dirty="0">
                         <a:latin typeface="Arial" charset="0"/>
@@ -16823,7 +16060,7 @@
                           <a:ea typeface="Arial" pitchFamily="34" charset="-122"/>
                           <a:cs typeface="Arial" pitchFamily="34" charset="-120"/>
                         </a:rPr>
-                        <a:t>L6总结</a:t>
+                        <a:t>L6</a:t>
                       </a:r>
                       <a:endParaRPr lang="en-US" sz="650" dirty="0">
                         <a:latin typeface="Arial" charset="0"/>
@@ -16940,7 +16177,7 @@
                   </a:tcPr>
                 </a:tc>
               </a:tr>
-              <a:tr h="150876">
+              <a:tr h="164592">
                 <a:tc>
                   <a:txBody>
                     <a:bodyPr/>
@@ -16958,7 +16195,7 @@
                           <a:ea typeface="Arial" pitchFamily="34" charset="-122"/>
                           <a:cs typeface="Arial" pitchFamily="34" charset="-120"/>
                         </a:rPr>
-                        <a:t>17:50</a:t>
+                        <a:t>17:25</a:t>
                       </a:r>
                       <a:endParaRPr lang="en-US" sz="650" dirty="0">
                         <a:latin typeface="Arial" charset="0"/>
@@ -17695,7 +16932,7 @@
                           <a:ea typeface="Arial" pitchFamily="34" charset="-122"/>
                           <a:cs typeface="Arial" pitchFamily="34" charset="-120"/>
                         </a:rPr>
-                        <a:t>~40% (上午)</a:t>
+                        <a:t>~40%</a:t>
                       </a:r>
                       <a:endParaRPr lang="en-US" sz="650" dirty="0">
                         <a:latin typeface="Arial" charset="0"/>
@@ -17827,7 +17064,7 @@
                           <a:ea typeface="Arial" pitchFamily="34" charset="-122"/>
                           <a:cs typeface="Arial" pitchFamily="34" charset="-120"/>
                         </a:rPr>
-                        <a:t>105min</a:t>
+                        <a:t>105min (L3)</a:t>
                       </a:r>
                       <a:endParaRPr lang="en-US" sz="650" dirty="0">
                         <a:latin typeface="Arial" charset="0"/>
@@ -17957,7 +17194,7 @@
                           <a:ea typeface="Arial" pitchFamily="34" charset="-122"/>
                           <a:cs typeface="Arial" pitchFamily="34" charset="-120"/>
                         </a:rPr>
-                        <a:t>195min (3 Workshop)</a:t>
+                        <a:t>270min (3 Workshop)</a:t>
                       </a:r>
                       <a:endParaRPr lang="en-US" sz="650" dirty="0">
                         <a:latin typeface="Arial" charset="0"/>
@@ -18329,7 +17566,7 @@
                   <a:srgbClr val="2563EB"/>
                 </a:solidFill>
               </a:rPr>
-              <a:t>上午讲座(到12:00)  下午先演示后演练  Workshop紧跟对应模块</a:t>
+              <a:t>上午讲座/演练  下午讲座/演练  Workshop紧跟对应模块</a:t>
             </a:r>
             <a:endParaRPr lang="en-US" sz="900" dirty="0"/>
           </a:p>

</xml_diff>